<commit_message>
Shorten decks to 7-9 slides and drop scoring/ranking
- Decks: 12/11/12 -> 7/8/9 slides; removed the rank slide, next-session
  info folded into each hands-on slide
- Notebooks: points and mob ranks replaced by a private progress()
  tracker (solved / still to do); nothing is scored or compared
- README updated to match

Co-Authored-By: Claude Opus 5.5 (1M context) <noreply@anthropic.com>
</commit_message>
<xml_diff>
--- a/slides/TBio_UDL_S2_Losses_Training_Ch5-6.pptx
+++ b/slides/TBio_UDL_S2_Losses_Training_Ch5-6.pptx
@@ -16,9 +16,6 @@
     <p:sldId id="261" r:id="rId19"/>
     <p:sldId id="262" r:id="rId20"/>
     <p:sldId id="263" r:id="rId21"/>
-    <p:sldId id="264" r:id="rId13"/>
-    <p:sldId id="265" r:id="rId12"/>
-    <p:sldId id="266" r:id="rId11"/>
   </p:sldIdLst>
   <p:sldSz cx="12192000" cy="6858000"/>
   <p:notesSz cx="6858000" cy="9144000"/>
@@ -857,76 +854,6 @@
 </p:notes>
 </file>
 
-<file path=ppt/notesSlides/notesSlide10.xml><?xml version="1.0" encoding="utf-8"?>
-<p:notes xmlns:a="http://schemas.openxmlformats.org/drawingml/2006/main" xmlns:p="http://schemas.openxmlformats.org/presentationml/2006/main" xmlns:r="http://schemas.openxmlformats.org/officeDocument/2006/relationships">
-  <p:cSld>
-    <p:spTree>
-      <p:nvGrpSpPr>
-        <p:cNvPr id="1" name=""/>
-        <p:cNvGrpSpPr/>
-        <p:nvPr/>
-      </p:nvGrpSpPr>
-      <p:grpSpPr>
-        <a:xfrm>
-          <a:off x="0" y="0"/>
-          <a:ext cx="0" cy="0"/>
-          <a:chOff x="0" y="0"/>
-          <a:chExt cx="0" cy="0"/>
-        </a:xfrm>
-      </p:grpSpPr>
-      <p:sp>
-        <p:nvSpPr>
-          <p:cNvPr id="2" name="Slide Image Placeholder 1"/>
-          <p:cNvSpPr>
-            <a:spLocks noGrp="1"/>
-          </p:cNvSpPr>
-          <p:nvPr>
-            <p:ph type="sldImg" idx="2"/>
-          </p:nvPr>
-        </p:nvSpPr>
-        <p:spPr/>
-      </p:sp>
-      <p:sp>
-        <p:nvSpPr>
-          <p:cNvPr id="3" name="Notes Placeholder 2"/>
-          <p:cNvSpPr>
-            <a:spLocks noGrp="1"/>
-          </p:cNvSpPr>
-          <p:nvPr>
-            <p:ph type="body" idx="3" sz="quarter"/>
-          </p:nvPr>
-        </p:nvSpPr>
-        <p:spPr/>
-        <p:txBody>
-          <a:bodyPr/>
-          <a:lstStyle/>
-          <a:p>
-            <a:r>
-              <a:t>Preview of the next session, plus homework.</a:t>
-            </a:r>
-          </a:p>
-        </p:txBody>
-      </p:sp>
-      <p:sp>
-        <p:nvSpPr>
-          <p:cNvPr id="4" name="Slide Number Placeholder 3"/>
-          <p:cNvSpPr>
-            <a:spLocks noGrp="1"/>
-          </p:cNvSpPr>
-          <p:nvPr>
-            <p:ph type="sldNum" idx="5" sz="quarter"/>
-          </p:nvPr>
-        </p:nvSpPr>
-        <p:spPr/>
-      </p:sp>
-    </p:spTree>
-  </p:cSld>
-  <p:clrMapOvr>
-    <a:masterClrMapping/>
-  </p:clrMapOvr>
-</p:notes>
-</file>
-
 <file path=ppt/notesSlides/notesSlide2.xml><?xml version="1.0" encoding="utf-8"?>
 <p:notes xmlns:a="http://schemas.openxmlformats.org/drawingml/2006/main" xmlns:p="http://schemas.openxmlformats.org/presentationml/2006/main" xmlns:r="http://schemas.openxmlformats.org/officeDocument/2006/relationships">
   <p:cSld>
@@ -1042,7 +969,7 @@
           <a:lstStyle/>
           <a:p>
             <a:r>
-              <a:t>Three sessions across chapters 1-8. Today is session 2: chapters 5–6.</a:t>
+              <a:t>Least squares is not arbitrary: it is the negative log-likelihood of a Gaussian. Same recipe gives BCE, cross-entropy, Poisson and von Mises losses, all used in Part 5 of the notebook.</a:t>
             </a:r>
           </a:p>
         </p:txBody>
@@ -1112,7 +1039,7 @@
           <a:lstStyle/>
           <a:p>
             <a:r>
-              <a:t>Least squares is not arbitrary: it is the negative log-likelihood of a Gaussian. Same recipe gives BCE, cross-entropy, Poisson and von Mises losses, all used in Part 5 of the notebook.</a:t>
+              <a:t>Normal NLL: the first term doesn't depend on phi, so argmin is least squares. Binary CE gradient sig(f)-y. Softmax gradient softmax(f)-onehot. Puzzle 5.6: averaging angles naively sends the mob east instead of west.</a:t>
             </a:r>
           </a:p>
         </p:txBody>
@@ -1182,7 +1109,7 @@
           <a:lstStyle/>
           <a:p>
             <a:r>
-              <a:t>Normal NLL: the first term doesn't depend on phi, so argmin is least squares. Binary CE gradient sig(f)-y. Softmax gradient softmax(f)-onehot. Puzzle 5.6: averaging angles naively sends the mob east instead of west.</a:t>
+              <a:t>Gabor model eq 6.8. GD from (1,12) and (2,19) reaches the global min; from (-6,20) and (3,15) it gets stuck. SGD occasionally escapes: from (3,15) it reached the global min in about 2 of 20 runs. No guarantees.</a:t>
             </a:r>
           </a:p>
         </p:txBody>
@@ -1252,7 +1179,7 @@
           <a:lstStyle/>
           <a:p>
             <a:r>
-              <a:t>Heteroscedastic regression: the network outputs mu and a raw variance, passed through softplus. Trained with Adam in PyTorch.</a:t>
+              <a:t>Momentum is an exponential moving average of gradients, weight (1-beta)beta^k (Puzzle 6.3). Adam normalises the step size per direction. Challenge 6: race to the burrow on a banana-shaped valley; Adam reaches it in 160 steps.</a:t>
             </a:r>
           </a:p>
         </p:txBody>
@@ -1278,146 +1205,6 @@
 </file>
 
 <file path=ppt/notesSlides/notesSlide7.xml><?xml version="1.0" encoding="utf-8"?>
-<p:notes xmlns:a="http://schemas.openxmlformats.org/drawingml/2006/main" xmlns:p="http://schemas.openxmlformats.org/presentationml/2006/main" xmlns:r="http://schemas.openxmlformats.org/officeDocument/2006/relationships">
-  <p:cSld>
-    <p:spTree>
-      <p:nvGrpSpPr>
-        <p:cNvPr id="1" name=""/>
-        <p:cNvGrpSpPr/>
-        <p:nvPr/>
-      </p:nvGrpSpPr>
-      <p:grpSpPr>
-        <a:xfrm>
-          <a:off x="0" y="0"/>
-          <a:ext cx="0" cy="0"/>
-          <a:chOff x="0" y="0"/>
-          <a:chExt cx="0" cy="0"/>
-        </a:xfrm>
-      </p:grpSpPr>
-      <p:sp>
-        <p:nvSpPr>
-          <p:cNvPr id="2" name="Slide Image Placeholder 1"/>
-          <p:cNvSpPr>
-            <a:spLocks noGrp="1"/>
-          </p:cNvSpPr>
-          <p:nvPr>
-            <p:ph type="sldImg" idx="2"/>
-          </p:nvPr>
-        </p:nvSpPr>
-        <p:spPr/>
-      </p:sp>
-      <p:sp>
-        <p:nvSpPr>
-          <p:cNvPr id="3" name="Notes Placeholder 2"/>
-          <p:cNvSpPr>
-            <a:spLocks noGrp="1"/>
-          </p:cNvSpPr>
-          <p:nvPr>
-            <p:ph type="body" idx="3" sz="quarter"/>
-          </p:nvPr>
-        </p:nvSpPr>
-        <p:spPr/>
-        <p:txBody>
-          <a:bodyPr/>
-          <a:lstStyle/>
-          <a:p>
-            <a:r>
-              <a:t>Gabor model eq 6.8. GD from (1,12) and (2,19) reaches the global min; from (-6,20) and (3,15) it gets stuck. SGD occasionally escapes: from (3,15) it reached the global min in about 2 of 20 runs. No guarantees.</a:t>
-            </a:r>
-          </a:p>
-        </p:txBody>
-      </p:sp>
-      <p:sp>
-        <p:nvSpPr>
-          <p:cNvPr id="4" name="Slide Number Placeholder 3"/>
-          <p:cNvSpPr>
-            <a:spLocks noGrp="1"/>
-          </p:cNvSpPr>
-          <p:nvPr>
-            <p:ph type="sldNum" idx="5" sz="quarter"/>
-          </p:nvPr>
-        </p:nvSpPr>
-        <p:spPr/>
-      </p:sp>
-    </p:spTree>
-  </p:cSld>
-  <p:clrMapOvr>
-    <a:masterClrMapping/>
-  </p:clrMapOvr>
-</p:notes>
-</file>
-
-<file path=ppt/notesSlides/notesSlide8.xml><?xml version="1.0" encoding="utf-8"?>
-<p:notes xmlns:a="http://schemas.openxmlformats.org/drawingml/2006/main" xmlns:p="http://schemas.openxmlformats.org/presentationml/2006/main" xmlns:r="http://schemas.openxmlformats.org/officeDocument/2006/relationships">
-  <p:cSld>
-    <p:spTree>
-      <p:nvGrpSpPr>
-        <p:cNvPr id="1" name=""/>
-        <p:cNvGrpSpPr/>
-        <p:nvPr/>
-      </p:nvGrpSpPr>
-      <p:grpSpPr>
-        <a:xfrm>
-          <a:off x="0" y="0"/>
-          <a:ext cx="0" cy="0"/>
-          <a:chOff x="0" y="0"/>
-          <a:chExt cx="0" cy="0"/>
-        </a:xfrm>
-      </p:grpSpPr>
-      <p:sp>
-        <p:nvSpPr>
-          <p:cNvPr id="2" name="Slide Image Placeholder 1"/>
-          <p:cNvSpPr>
-            <a:spLocks noGrp="1"/>
-          </p:cNvSpPr>
-          <p:nvPr>
-            <p:ph type="sldImg" idx="2"/>
-          </p:nvPr>
-        </p:nvSpPr>
-        <p:spPr/>
-      </p:sp>
-      <p:sp>
-        <p:nvSpPr>
-          <p:cNvPr id="3" name="Notes Placeholder 2"/>
-          <p:cNvSpPr>
-            <a:spLocks noGrp="1"/>
-          </p:cNvSpPr>
-          <p:nvPr>
-            <p:ph type="body" idx="3" sz="quarter"/>
-          </p:nvPr>
-        </p:nvSpPr>
-        <p:spPr/>
-        <p:txBody>
-          <a:bodyPr/>
-          <a:lstStyle/>
-          <a:p>
-            <a:r>
-              <a:t>Momentum is an exponential moving average of gradients, weight (1-beta)beta^k (Puzzle 6.3). Adam normalises the step size per direction. Challenge 6: race to the burrow on a banana-shaped valley; Adam reaches it in 160 steps.</a:t>
-            </a:r>
-          </a:p>
-        </p:txBody>
-      </p:sp>
-      <p:sp>
-        <p:nvSpPr>
-          <p:cNvPr id="4" name="Slide Number Placeholder 3"/>
-          <p:cNvSpPr>
-            <a:spLocks noGrp="1"/>
-          </p:cNvSpPr>
-          <p:nvPr>
-            <p:ph type="sldNum" idx="5" sz="quarter"/>
-          </p:nvPr>
-        </p:nvSpPr>
-        <p:spPr/>
-      </p:sp>
-    </p:spTree>
-  </p:cSld>
-  <p:clrMapOvr>
-    <a:masterClrMapping/>
-  </p:clrMapOvr>
-</p:notes>
-</file>
-
-<file path=ppt/notesSlides/notesSlide9.xml><?xml version="1.0" encoding="utf-8"?>
 <p:notes xmlns:a="http://schemas.openxmlformats.org/drawingml/2006/main" xmlns:p="http://schemas.openxmlformats.org/presentationml/2006/main" xmlns:r="http://schemas.openxmlformats.org/officeDocument/2006/relationships">
   <p:cSld>
     <p:spTree>
@@ -3800,7 +3587,7 @@
 </p:sld>
 </file>
 
-<file path=ppt/slides/slide10.xml><?xml version="1.0" encoding="utf-8"?>
+<file path=ppt/slides/slide2.xml><?xml version="1.0" encoding="utf-8"?>
 <p:sld xmlns:a="http://schemas.openxmlformats.org/drawingml/2006/main" xmlns:p="http://schemas.openxmlformats.org/presentationml/2006/main" xmlns:r="http://schemas.openxmlformats.org/officeDocument/2006/relationships">
   <p:cSld>
     <p:spTree>
@@ -3827,11 +3614,11 @@
           <a:p>
             <a:r>
               <a:rPr b="1"/>
-              <a:t>Next time: </a:t>
+              <a:t>Last time: </a:t>
             </a:r>
             <a:r>
               <a:rPr b="0"/>
-              <a:t>Session 3</a:t>
+              <a:t>models (Ch 1–4)</a:t>
             </a:r>
           </a:p>
         </p:txBody>
@@ -3867,7 +3654,149 @@
         <p:spPr>
           <a:xfrm>
             <a:off x="548640" y="1417320"/>
-            <a:ext cx="6309360" cy="4023360"/>
+            <a:ext cx="5349240" cy="2011680"/>
+          </a:xfrm>
+          <a:prstGeom prst="roundRect">
+            <a:avLst>
+              <a:gd name="adj" fmla="val 4000"/>
+            </a:avLst>
+          </a:prstGeom>
+          <a:solidFill>
+            <a:srgbClr val="FFFFFF"/>
+          </a:solidFill>
+          <a:ln w="15875">
+            <a:solidFill>
+              <a:srgbClr val="1366AB"/>
+            </a:solidFill>
+          </a:ln>
+          <a:effectLst/>
+        </p:spPr>
+        <p:style>
+          <a:lnRef idx="1">
+            <a:schemeClr val="accent1"/>
+          </a:lnRef>
+          <a:fillRef idx="3">
+            <a:schemeClr val="accent1"/>
+          </a:fillRef>
+          <a:effectRef idx="2">
+            <a:schemeClr val="accent1"/>
+          </a:effectRef>
+          <a:fontRef idx="minor">
+            <a:schemeClr val="lt1"/>
+          </a:fontRef>
+        </p:style>
+        <p:txBody>
+          <a:bodyPr rtlCol="0" anchor="ctr"/>
+          <a:lstStyle/>
+          <a:p>
+            <a:pPr algn="ctr"/>
+          </a:p>
+        </p:txBody>
+      </p:sp>
+      <p:sp>
+        <p:nvSpPr>
+          <p:cNvPr id="7" name="Rounded Rectangle 6"/>
+          <p:cNvSpPr/>
+          <p:nvPr/>
+        </p:nvSpPr>
+        <p:spPr>
+          <a:xfrm>
+            <a:off x="685800" y="1554480"/>
+            <a:ext cx="2926080" cy="310896"/>
+          </a:xfrm>
+          <a:prstGeom prst="roundRect">
+            <a:avLst>
+              <a:gd name="adj" fmla="val 25000"/>
+            </a:avLst>
+          </a:prstGeom>
+          <a:solidFill>
+            <a:srgbClr val="1366AB"/>
+          </a:solidFill>
+          <a:ln>
+            <a:noFill/>
+          </a:ln>
+          <a:effectLst/>
+        </p:spPr>
+        <p:style>
+          <a:lnRef idx="1">
+            <a:schemeClr val="accent1"/>
+          </a:lnRef>
+          <a:fillRef idx="3">
+            <a:schemeClr val="accent1"/>
+          </a:fillRef>
+          <a:effectRef idx="2">
+            <a:schemeClr val="accent1"/>
+          </a:effectRef>
+          <a:fontRef idx="minor">
+            <a:schemeClr val="lt1"/>
+          </a:fontRef>
+        </p:style>
+        <p:txBody>
+          <a:bodyPr rtlCol="0" anchor="ctr" tIns="9144" bIns="9144"/>
+          <a:lstStyle/>
+          <a:p>
+            <a:pPr algn="ctr"/>
+            <a:r>
+              <a:rPr sz="1200" b="1">
+                <a:solidFill>
+                  <a:srgbClr val="FFFFFF"/>
+                </a:solidFill>
+                <a:latin typeface="Calibri"/>
+              </a:rPr>
+              <a:t>SUPERVISED LEARNING</a:t>
+            </a:r>
+          </a:p>
+        </p:txBody>
+      </p:sp>
+      <p:sp>
+        <p:nvSpPr>
+          <p:cNvPr id="8" name="TextBox 7"/>
+          <p:cNvSpPr txBox="1"/>
+          <p:nvPr/>
+        </p:nvSpPr>
+        <p:spPr>
+          <a:xfrm>
+            <a:off x="685800" y="2011680"/>
+            <a:ext cx="5074920" cy="1325880"/>
+          </a:xfrm>
+          <a:prstGeom prst="rect">
+            <a:avLst/>
+          </a:prstGeom>
+          <a:noFill/>
+        </p:spPr>
+        <p:txBody>
+          <a:bodyPr wrap="square" lIns="45720" rIns="45720" tIns="27432" bIns="27432" anchor="t">
+            <a:spAutoFit/>
+          </a:bodyPr>
+          <a:lstStyle/>
+          <a:p>
+            <a:pPr algn="l">
+              <a:spcAft>
+                <a:spcPts val="600"/>
+              </a:spcAft>
+            </a:pPr>
+            <a:r>
+              <a:rPr sz="1600" b="0" i="0">
+                <a:solidFill>
+                  <a:srgbClr val="404040"/>
+                </a:solidFill>
+                <a:latin typeface="Calibri"/>
+              </a:rPr>
+              <a:t>A model is a family y = f[x, ϕ]; training = argmin of a loss. Least squares + gradient descent.</a:t>
+            </a:r>
+          </a:p>
+        </p:txBody>
+      </p:sp>
+      <p:sp>
+        <p:nvSpPr>
+          <p:cNvPr id="9" name="Rounded Rectangle 8"/>
+          <p:cNvSpPr/>
+          <p:nvPr/>
+        </p:nvSpPr>
+        <p:spPr>
+          <a:xfrm>
+            <a:off x="6126479" y="1417320"/>
+            <a:ext cx="5349240" cy="2011680"/>
           </a:xfrm>
           <a:prstGeom prst="roundRect">
             <a:avLst>
@@ -3908,667 +3837,6 @@
       </p:sp>
       <p:sp>
         <p:nvSpPr>
-          <p:cNvPr id="7" name="Rounded Rectangle 6"/>
-          <p:cNvSpPr/>
-          <p:nvPr/>
-        </p:nvSpPr>
-        <p:spPr>
-          <a:xfrm>
-            <a:off x="685800" y="1554480"/>
-            <a:ext cx="5029200" cy="310896"/>
-          </a:xfrm>
-          <a:prstGeom prst="roundRect">
-            <a:avLst>
-              <a:gd name="adj" fmla="val 25000"/>
-            </a:avLst>
-          </a:prstGeom>
-          <a:solidFill>
-            <a:srgbClr val="008759"/>
-          </a:solidFill>
-          <a:ln>
-            <a:noFill/>
-          </a:ln>
-          <a:effectLst/>
-        </p:spPr>
-        <p:style>
-          <a:lnRef idx="1">
-            <a:schemeClr val="accent1"/>
-          </a:lnRef>
-          <a:fillRef idx="3">
-            <a:schemeClr val="accent1"/>
-          </a:fillRef>
-          <a:effectRef idx="2">
-            <a:schemeClr val="accent1"/>
-          </a:effectRef>
-          <a:fontRef idx="minor">
-            <a:schemeClr val="lt1"/>
-          </a:fontRef>
-        </p:style>
-        <p:txBody>
-          <a:bodyPr rtlCol="0" anchor="ctr" tIns="9144" bIns="9144"/>
-          <a:lstStyle/>
-          <a:p>
-            <a:pPr algn="ctr"/>
-            <a:r>
-              <a:rPr sz="1200" b="1">
-                <a:solidFill>
-                  <a:srgbClr val="FFFFFF"/>
-                </a:solidFill>
-                <a:latin typeface="Calibri"/>
-              </a:rPr>
-              <a:t>BACKPROP AND PERFORMANCE · CH 7–8</a:t>
-            </a:r>
-          </a:p>
-        </p:txBody>
-      </p:sp>
-      <p:sp>
-        <p:nvSpPr>
-          <p:cNvPr id="8" name="TextBox 7"/>
-          <p:cNvSpPr txBox="1"/>
-          <p:nvPr/>
-        </p:nvSpPr>
-        <p:spPr>
-          <a:xfrm>
-            <a:off x="731520" y="2057400"/>
-            <a:ext cx="5943600" cy="3291840"/>
-          </a:xfrm>
-          <a:prstGeom prst="rect">
-            <a:avLst/>
-          </a:prstGeom>
-          <a:noFill/>
-        </p:spPr>
-        <p:txBody>
-          <a:bodyPr wrap="square" lIns="45720" rIns="45720" tIns="27432" bIns="27432" anchor="t">
-            <a:spAutoFit/>
-          </a:bodyPr>
-          <a:lstStyle/>
-          <a:p>
-            <a:pPr algn="l" marL="201168" indent="-182880">
-              <a:spcAft>
-                <a:spcPts val="1200"/>
-              </a:spcAft>
-              <a:buFont typeface="Arial"/>
-              <a:buChar char="•"/>
-            </a:pPr>
-            <a:r>
-              <a:rPr sz="1700" b="0" i="0">
-                <a:solidFill>
-                  <a:srgbClr val="404040"/>
-                </a:solidFill>
-                <a:latin typeface="Calibri"/>
-              </a:rPr>
-              <a:t>Backpropagation by hand, then for any MLP</a:t>
-            </a:r>
-          </a:p>
-          <a:p>
-            <a:pPr algn="l" marL="201168" indent="-182880">
-              <a:spcAft>
-                <a:spcPts val="1200"/>
-              </a:spcAft>
-              <a:buFont typeface="Arial"/>
-              <a:buChar char="•"/>
-            </a:pPr>
-            <a:r>
-              <a:rPr sz="1700" b="0" i="0">
-                <a:solidFill>
-                  <a:srgbClr val="404040"/>
-                </a:solidFill>
-                <a:latin typeface="Calibri"/>
-              </a:rPr>
-              <a:t>Initialisation: whispers down the burrow</a:t>
-            </a:r>
-          </a:p>
-          <a:p>
-            <a:pPr algn="l" marL="201168" indent="-182880">
-              <a:spcAft>
-                <a:spcPts val="1200"/>
-              </a:spcAft>
-              <a:buFont typeface="Arial"/>
-              <a:buChar char="•"/>
-            </a:pPr>
-            <a:r>
-              <a:rPr sz="1700" b="0" i="0">
-                <a:solidFill>
-                  <a:srgbClr val="404040"/>
-                </a:solidFill>
-                <a:latin typeface="Calibri"/>
-              </a:rPr>
-              <a:t>Bias, variance and double descent</a:t>
-            </a:r>
-          </a:p>
-          <a:p>
-            <a:pPr algn="l" marL="201168" indent="-182880">
-              <a:spcAft>
-                <a:spcPts val="1200"/>
-              </a:spcAft>
-              <a:buFont typeface="Arial"/>
-              <a:buChar char="•"/>
-            </a:pPr>
-            <a:r>
-              <a:rPr sz="1700" b="0" i="0">
-                <a:solidFill>
-                  <a:srgbClr val="404040"/>
-                </a:solidFill>
-                <a:latin typeface="Calibri"/>
-              </a:rPr>
-              <a:t>Capstone: from meerkats to molecules</a:t>
-            </a:r>
-          </a:p>
-        </p:txBody>
-      </p:sp>
-      <p:sp>
-        <p:nvSpPr>
-          <p:cNvPr id="9" name="Rounded Rectangle 8"/>
-          <p:cNvSpPr/>
-          <p:nvPr/>
-        </p:nvSpPr>
-        <p:spPr>
-          <a:xfrm>
-            <a:off x="7132320" y="1417320"/>
-            <a:ext cx="4480560" cy="4023360"/>
-          </a:xfrm>
-          <a:prstGeom prst="roundRect">
-            <a:avLst>
-              <a:gd name="adj" fmla="val 4000"/>
-            </a:avLst>
-          </a:prstGeom>
-          <a:solidFill>
-            <a:srgbClr val="FFF8EE"/>
-          </a:solidFill>
-          <a:ln w="15875">
-            <a:solidFill>
-              <a:srgbClr val="EF8E00"/>
-            </a:solidFill>
-          </a:ln>
-          <a:effectLst/>
-        </p:spPr>
-        <p:style>
-          <a:lnRef idx="1">
-            <a:schemeClr val="accent1"/>
-          </a:lnRef>
-          <a:fillRef idx="3">
-            <a:schemeClr val="accent1"/>
-          </a:fillRef>
-          <a:effectRef idx="2">
-            <a:schemeClr val="accent1"/>
-          </a:effectRef>
-          <a:fontRef idx="minor">
-            <a:schemeClr val="lt1"/>
-          </a:fontRef>
-        </p:style>
-        <p:txBody>
-          <a:bodyPr rtlCol="0" anchor="ctr"/>
-          <a:lstStyle/>
-          <a:p>
-            <a:pPr algn="ctr"/>
-          </a:p>
-        </p:txBody>
-      </p:sp>
-      <p:sp>
-        <p:nvSpPr>
-          <p:cNvPr id="10" name="Rounded Rectangle 9"/>
-          <p:cNvSpPr/>
-          <p:nvPr/>
-        </p:nvSpPr>
-        <p:spPr>
-          <a:xfrm>
-            <a:off x="7269480" y="1554480"/>
-            <a:ext cx="2194560" cy="310896"/>
-          </a:xfrm>
-          <a:prstGeom prst="roundRect">
-            <a:avLst>
-              <a:gd name="adj" fmla="val 25000"/>
-            </a:avLst>
-          </a:prstGeom>
-          <a:solidFill>
-            <a:srgbClr val="EF8E00"/>
-          </a:solidFill>
-          <a:ln>
-            <a:noFill/>
-          </a:ln>
-          <a:effectLst/>
-        </p:spPr>
-        <p:style>
-          <a:lnRef idx="1">
-            <a:schemeClr val="accent1"/>
-          </a:lnRef>
-          <a:fillRef idx="3">
-            <a:schemeClr val="accent1"/>
-          </a:fillRef>
-          <a:effectRef idx="2">
-            <a:schemeClr val="accent1"/>
-          </a:effectRef>
-          <a:fontRef idx="minor">
-            <a:schemeClr val="lt1"/>
-          </a:fontRef>
-        </p:style>
-        <p:txBody>
-          <a:bodyPr rtlCol="0" anchor="ctr" tIns="9144" bIns="9144"/>
-          <a:lstStyle/>
-          <a:p>
-            <a:pPr algn="ctr"/>
-            <a:r>
-              <a:rPr sz="1200" b="1">
-                <a:solidFill>
-                  <a:srgbClr val="FFFFFF"/>
-                </a:solidFill>
-                <a:latin typeface="Calibri"/>
-              </a:rPr>
-              <a:t>HOMEWORK</a:t>
-            </a:r>
-          </a:p>
-        </p:txBody>
-      </p:sp>
-      <p:sp>
-        <p:nvSpPr>
-          <p:cNvPr id="11" name="TextBox 10"/>
-          <p:cNvSpPr txBox="1"/>
-          <p:nvPr/>
-        </p:nvSpPr>
-        <p:spPr>
-          <a:xfrm>
-            <a:off x="7269480" y="2057400"/>
-            <a:ext cx="4206240" cy="3291840"/>
-          </a:xfrm>
-          <a:prstGeom prst="rect">
-            <a:avLst/>
-          </a:prstGeom>
-          <a:noFill/>
-        </p:spPr>
-        <p:txBody>
-          <a:bodyPr wrap="square" lIns="45720" rIns="45720" tIns="27432" bIns="27432" anchor="t">
-            <a:spAutoFit/>
-          </a:bodyPr>
-          <a:lstStyle/>
-          <a:p>
-            <a:pPr algn="l">
-              <a:spcAft>
-                <a:spcPts val="1000"/>
-              </a:spcAft>
-            </a:pPr>
-            <a:r>
-              <a:rPr sz="1600" b="0" i="0">
-                <a:solidFill>
-                  <a:srgbClr val="404040"/>
-                </a:solidFill>
-                <a:latin typeface="Calibri"/>
-              </a:rPr>
-              <a:t>Finish any puzzles from today, especially the stretch ones (5.2, 5.6, 6.3).</a:t>
-            </a:r>
-          </a:p>
-          <a:p>
-            <a:pPr algn="l">
-              <a:spcAft>
-                <a:spcPts val="1000"/>
-              </a:spcAft>
-            </a:pPr>
-            <a:r>
-              <a:rPr sz="1600" b="0" i="0">
-                <a:solidFill>
-                  <a:srgbClr val="404040"/>
-                </a:solidFill>
-                <a:latin typeface="Calibri"/>
-              </a:rPr>
-              <a:t>Note your score from scoreboard(): the series total is out of 72.</a:t>
-            </a:r>
-          </a:p>
-          <a:p>
-            <a:pPr algn="l">
-              <a:spcAft>
-                <a:spcPts val="600"/>
-              </a:spcAft>
-            </a:pPr>
-            <a:r>
-              <a:rPr sz="1600" b="0" i="0">
-                <a:solidFill>
-                  <a:srgbClr val="404040"/>
-                </a:solidFill>
-                <a:latin typeface="Calibri"/>
-              </a:rPr>
-              <a:t>Optional reading: book chapters 7–8.</a:t>
-            </a:r>
-          </a:p>
-        </p:txBody>
-      </p:sp>
-    </p:spTree>
-  </p:cSld>
-  <p:clrMapOvr>
-    <a:masterClrMapping/>
-  </p:clrMapOvr>
-</p:sld>
-</file>
-
-<file path=ppt/slides/slide11.xml><?xml version="1.0" encoding="utf-8"?>
-<p:sld xmlns:a="http://schemas.openxmlformats.org/drawingml/2006/main" xmlns:p="http://schemas.openxmlformats.org/presentationml/2006/main" xmlns:r="http://schemas.openxmlformats.org/officeDocument/2006/relationships">
-  <p:cSld>
-    <p:spTree>
-      <p:nvGrpSpPr>
-        <p:cNvPr id="1" name=""/>
-        <p:cNvGrpSpPr/>
-        <p:nvPr/>
-      </p:nvGrpSpPr>
-      <p:grpSpPr/>
-      <p:sp>
-        <p:nvSpPr>
-          <p:cNvPr id="2" name="Text Placeholder 1"/>
-          <p:cNvSpPr>
-            <a:spLocks noGrp="1"/>
-          </p:cNvSpPr>
-          <p:nvPr>
-            <p:ph type="body" idx="12" sz="quarter"/>
-          </p:nvPr>
-        </p:nvSpPr>
-        <p:spPr/>
-        <p:txBody>
-          <a:bodyPr/>
-          <a:lstStyle/>
-          <a:p>
-            <a:r>
-              <a:t>Transition Bio ML Reading Group</a:t>
-            </a:r>
-          </a:p>
-        </p:txBody>
-      </p:sp>
-      <p:sp>
-        <p:nvSpPr>
-          <p:cNvPr id="3" name="Title 2"/>
-          <p:cNvSpPr>
-            <a:spLocks noGrp="1"/>
-          </p:cNvSpPr>
-          <p:nvPr>
-            <p:ph type="ctrTitle"/>
-          </p:nvPr>
-        </p:nvSpPr>
-        <p:spPr/>
-        <p:txBody>
-          <a:bodyPr/>
-          <a:lstStyle/>
-          <a:p>
-            <a:r>
-              <a:t>Questions?</a:t>
-            </a:r>
-          </a:p>
-        </p:txBody>
-      </p:sp>
-      <p:sp>
-        <p:nvSpPr>
-          <p:cNvPr id="4" name="Text Placeholder 3"/>
-          <p:cNvSpPr>
-            <a:spLocks noGrp="1"/>
-          </p:cNvSpPr>
-          <p:nvPr>
-            <p:ph type="body" idx="11" sz="quarter"/>
-          </p:nvPr>
-        </p:nvSpPr>
-        <p:spPr/>
-        <p:txBody>
-          <a:bodyPr/>
-          <a:lstStyle/>
-          <a:p>
-            <a:r>
-              <a:t>Deep Learning in the Kalahari</a:t>
-            </a:r>
-          </a:p>
-        </p:txBody>
-      </p:sp>
-    </p:spTree>
-  </p:cSld>
-  <p:clrMapOvr>
-    <a:masterClrMapping/>
-  </p:clrMapOvr>
-</p:sld>
-</file>
-
-<file path=ppt/slides/slide2.xml><?xml version="1.0" encoding="utf-8"?>
-<p:sld xmlns:a="http://schemas.openxmlformats.org/drawingml/2006/main" xmlns:p="http://schemas.openxmlformats.org/presentationml/2006/main" xmlns:r="http://schemas.openxmlformats.org/officeDocument/2006/relationships">
-  <p:cSld>
-    <p:spTree>
-      <p:nvGrpSpPr>
-        <p:cNvPr id="1" name=""/>
-        <p:cNvGrpSpPr/>
-        <p:nvPr/>
-      </p:nvGrpSpPr>
-      <p:grpSpPr/>
-      <p:sp>
-        <p:nvSpPr>
-          <p:cNvPr id="2" name="Title 1"/>
-          <p:cNvSpPr>
-            <a:spLocks noGrp="1"/>
-          </p:cNvSpPr>
-          <p:nvPr>
-            <p:ph type="title"/>
-          </p:nvPr>
-        </p:nvSpPr>
-        <p:spPr/>
-        <p:txBody>
-          <a:bodyPr/>
-          <a:lstStyle/>
-          <a:p>
-            <a:r>
-              <a:rPr b="1"/>
-              <a:t>Last time: </a:t>
-            </a:r>
-            <a:r>
-              <a:rPr b="0"/>
-              <a:t>models (Ch 1–4)</a:t>
-            </a:r>
-          </a:p>
-        </p:txBody>
-      </p:sp>
-      <p:sp>
-        <p:nvSpPr>
-          <p:cNvPr id="5" name="Slide Number Placeholder 4"/>
-          <p:cNvSpPr>
-            <a:spLocks noGrp="1"/>
-          </p:cNvSpPr>
-          <p:nvPr>
-            <p:ph type="sldNum" sz="quarter" idx="12"/>
-          </p:nvPr>
-        </p:nvSpPr>
-        <p:spPr/>
-        <p:txBody>
-          <a:bodyPr/>
-          <a:lstStyle/>
-          <a:p>
-            <a:fld id="{B6F15528-21DE-4FAA-801E-634DDDAF4B2B}" type="slidenum">
-              <a:rPr lang="en-US"/>
-              <a:t>‹#›</a:t>
-            </a:fld>
-          </a:p>
-        </p:txBody>
-      </p:sp>
-      <p:sp>
-        <p:nvSpPr>
-          <p:cNvPr id="6" name="Rounded Rectangle 5"/>
-          <p:cNvSpPr/>
-          <p:nvPr/>
-        </p:nvSpPr>
-        <p:spPr>
-          <a:xfrm>
-            <a:off x="548640" y="1417320"/>
-            <a:ext cx="5349240" cy="2011680"/>
-          </a:xfrm>
-          <a:prstGeom prst="roundRect">
-            <a:avLst>
-              <a:gd name="adj" fmla="val 4000"/>
-            </a:avLst>
-          </a:prstGeom>
-          <a:solidFill>
-            <a:srgbClr val="FFFFFF"/>
-          </a:solidFill>
-          <a:ln w="15875">
-            <a:solidFill>
-              <a:srgbClr val="1366AB"/>
-            </a:solidFill>
-          </a:ln>
-          <a:effectLst/>
-        </p:spPr>
-        <p:style>
-          <a:lnRef idx="1">
-            <a:schemeClr val="accent1"/>
-          </a:lnRef>
-          <a:fillRef idx="3">
-            <a:schemeClr val="accent1"/>
-          </a:fillRef>
-          <a:effectRef idx="2">
-            <a:schemeClr val="accent1"/>
-          </a:effectRef>
-          <a:fontRef idx="minor">
-            <a:schemeClr val="lt1"/>
-          </a:fontRef>
-        </p:style>
-        <p:txBody>
-          <a:bodyPr rtlCol="0" anchor="ctr"/>
-          <a:lstStyle/>
-          <a:p>
-            <a:pPr algn="ctr"/>
-          </a:p>
-        </p:txBody>
-      </p:sp>
-      <p:sp>
-        <p:nvSpPr>
-          <p:cNvPr id="7" name="Rounded Rectangle 6"/>
-          <p:cNvSpPr/>
-          <p:nvPr/>
-        </p:nvSpPr>
-        <p:spPr>
-          <a:xfrm>
-            <a:off x="685800" y="1554480"/>
-            <a:ext cx="2926080" cy="310896"/>
-          </a:xfrm>
-          <a:prstGeom prst="roundRect">
-            <a:avLst>
-              <a:gd name="adj" fmla="val 25000"/>
-            </a:avLst>
-          </a:prstGeom>
-          <a:solidFill>
-            <a:srgbClr val="1366AB"/>
-          </a:solidFill>
-          <a:ln>
-            <a:noFill/>
-          </a:ln>
-          <a:effectLst/>
-        </p:spPr>
-        <p:style>
-          <a:lnRef idx="1">
-            <a:schemeClr val="accent1"/>
-          </a:lnRef>
-          <a:fillRef idx="3">
-            <a:schemeClr val="accent1"/>
-          </a:fillRef>
-          <a:effectRef idx="2">
-            <a:schemeClr val="accent1"/>
-          </a:effectRef>
-          <a:fontRef idx="minor">
-            <a:schemeClr val="lt1"/>
-          </a:fontRef>
-        </p:style>
-        <p:txBody>
-          <a:bodyPr rtlCol="0" anchor="ctr" tIns="9144" bIns="9144"/>
-          <a:lstStyle/>
-          <a:p>
-            <a:pPr algn="ctr"/>
-            <a:r>
-              <a:rPr sz="1200" b="1">
-                <a:solidFill>
-                  <a:srgbClr val="FFFFFF"/>
-                </a:solidFill>
-                <a:latin typeface="Calibri"/>
-              </a:rPr>
-              <a:t>SUPERVISED LEARNING</a:t>
-            </a:r>
-          </a:p>
-        </p:txBody>
-      </p:sp>
-      <p:sp>
-        <p:nvSpPr>
-          <p:cNvPr id="8" name="TextBox 7"/>
-          <p:cNvSpPr txBox="1"/>
-          <p:nvPr/>
-        </p:nvSpPr>
-        <p:spPr>
-          <a:xfrm>
-            <a:off x="685800" y="2011680"/>
-            <a:ext cx="5074920" cy="1325880"/>
-          </a:xfrm>
-          <a:prstGeom prst="rect">
-            <a:avLst/>
-          </a:prstGeom>
-          <a:noFill/>
-        </p:spPr>
-        <p:txBody>
-          <a:bodyPr wrap="square" lIns="45720" rIns="45720" tIns="27432" bIns="27432" anchor="t">
-            <a:spAutoFit/>
-          </a:bodyPr>
-          <a:lstStyle/>
-          <a:p>
-            <a:pPr algn="l">
-              <a:spcAft>
-                <a:spcPts val="600"/>
-              </a:spcAft>
-            </a:pPr>
-            <a:r>
-              <a:rPr sz="1600" b="0" i="0">
-                <a:solidFill>
-                  <a:srgbClr val="404040"/>
-                </a:solidFill>
-                <a:latin typeface="Calibri"/>
-              </a:rPr>
-              <a:t>A model is a family y = f[x, ϕ]; training = argmin of a loss. Least squares + gradient descent.</a:t>
-            </a:r>
-          </a:p>
-        </p:txBody>
-      </p:sp>
-      <p:sp>
-        <p:nvSpPr>
-          <p:cNvPr id="9" name="Rounded Rectangle 8"/>
-          <p:cNvSpPr/>
-          <p:nvPr/>
-        </p:nvSpPr>
-        <p:spPr>
-          <a:xfrm>
-            <a:off x="6126479" y="1417320"/>
-            <a:ext cx="5349240" cy="2011680"/>
-          </a:xfrm>
-          <a:prstGeom prst="roundRect">
-            <a:avLst>
-              <a:gd name="adj" fmla="val 4000"/>
-            </a:avLst>
-          </a:prstGeom>
-          <a:solidFill>
-            <a:srgbClr val="FFFFFF"/>
-          </a:solidFill>
-          <a:ln w="15875">
-            <a:solidFill>
-              <a:srgbClr val="008759"/>
-            </a:solidFill>
-          </a:ln>
-          <a:effectLst/>
-        </p:spPr>
-        <p:style>
-          <a:lnRef idx="1">
-            <a:schemeClr val="accent1"/>
-          </a:lnRef>
-          <a:fillRef idx="3">
-            <a:schemeClr val="accent1"/>
-          </a:fillRef>
-          <a:effectRef idx="2">
-            <a:schemeClr val="accent1"/>
-          </a:effectRef>
-          <a:fontRef idx="minor">
-            <a:schemeClr val="lt1"/>
-          </a:fontRef>
-        </p:style>
-        <p:txBody>
-          <a:bodyPr rtlCol="0" anchor="ctr"/>
-          <a:lstStyle/>
-          <a:p>
-            <a:pPr algn="ctr"/>
-          </a:p>
-        </p:txBody>
-      </p:sp>
-      <p:sp>
-        <p:nvSpPr>
           <p:cNvPr id="10" name="Rounded Rectangle 9"/>
           <p:cNvSpPr/>
           <p:nvPr/>
@@ -4954,1404 +4222,6 @@
 </file>
 
 <file path=ppt/slides/slide3.xml><?xml version="1.0" encoding="utf-8"?>
-<p:sld xmlns:a="http://schemas.openxmlformats.org/drawingml/2006/main" xmlns:p="http://schemas.openxmlformats.org/presentationml/2006/main" xmlns:r="http://schemas.openxmlformats.org/officeDocument/2006/relationships">
-  <p:cSld>
-    <p:spTree>
-      <p:nvGrpSpPr>
-        <p:cNvPr id="1" name=""/>
-        <p:cNvGrpSpPr/>
-        <p:nvPr/>
-      </p:nvGrpSpPr>
-      <p:grpSpPr/>
-      <p:sp>
-        <p:nvSpPr>
-          <p:cNvPr id="2" name="Title 1"/>
-          <p:cNvSpPr>
-            <a:spLocks noGrp="1"/>
-          </p:cNvSpPr>
-          <p:nvPr>
-            <p:ph type="title"/>
-          </p:nvPr>
-        </p:nvSpPr>
-        <p:spPr/>
-        <p:txBody>
-          <a:bodyPr/>
-          <a:lstStyle/>
-          <a:p>
-            <a:r>
-              <a:rPr b="1"/>
-              <a:t>The series: </a:t>
-            </a:r>
-            <a:r>
-              <a:rPr b="0"/>
-              <a:t>model → loss → fit → measure</a:t>
-            </a:r>
-          </a:p>
-        </p:txBody>
-      </p:sp>
-      <p:sp>
-        <p:nvSpPr>
-          <p:cNvPr id="5" name="Slide Number Placeholder 4"/>
-          <p:cNvSpPr>
-            <a:spLocks noGrp="1"/>
-          </p:cNvSpPr>
-          <p:nvPr>
-            <p:ph type="sldNum" sz="quarter" idx="12"/>
-          </p:nvPr>
-        </p:nvSpPr>
-        <p:spPr/>
-        <p:txBody>
-          <a:bodyPr/>
-          <a:lstStyle/>
-          <a:p>
-            <a:fld id="{B6F15528-21DE-4FAA-801E-634DDDAF4B2B}" type="slidenum">
-              <a:rPr lang="en-US"/>
-              <a:t>‹#›</a:t>
-            </a:fld>
-          </a:p>
-        </p:txBody>
-      </p:sp>
-      <p:sp>
-        <p:nvSpPr>
-          <p:cNvPr id="6" name="Pentagon 5"/>
-          <p:cNvSpPr/>
-          <p:nvPr/>
-        </p:nvSpPr>
-        <p:spPr>
-          <a:xfrm>
-            <a:off x="502920" y="1417320"/>
-            <a:ext cx="1481328" cy="685800"/>
-          </a:xfrm>
-          <a:prstGeom prst="homePlate">
-            <a:avLst/>
-          </a:prstGeom>
-          <a:solidFill>
-            <a:srgbClr val="DCDDDC"/>
-          </a:solidFill>
-          <a:ln>
-            <a:noFill/>
-          </a:ln>
-          <a:effectLst/>
-        </p:spPr>
-        <p:style>
-          <a:lnRef idx="1">
-            <a:schemeClr val="accent1"/>
-          </a:lnRef>
-          <a:fillRef idx="3">
-            <a:schemeClr val="accent1"/>
-          </a:fillRef>
-          <a:effectRef idx="2">
-            <a:schemeClr val="accent1"/>
-          </a:effectRef>
-          <a:fontRef idx="minor">
-            <a:schemeClr val="lt1"/>
-          </a:fontRef>
-        </p:style>
-        <p:txBody>
-          <a:bodyPr rtlCol="0" anchor="ctr" wrap="square" lIns="54864" rIns="54864"/>
-          <a:lstStyle/>
-          <a:p>
-            <a:pPr algn="ctr"/>
-            <a:r>
-              <a:rPr sz="1700" b="1">
-                <a:solidFill>
-                  <a:srgbClr val="595959"/>
-                </a:solidFill>
-                <a:latin typeface="Calibri"/>
-              </a:rPr>
-              <a:t>Ch 1</a:t>
-            </a:r>
-          </a:p>
-        </p:txBody>
-      </p:sp>
-      <p:sp>
-        <p:nvSpPr>
-          <p:cNvPr id="7" name="TextBox 6"/>
-          <p:cNvSpPr txBox="1"/>
-          <p:nvPr/>
-        </p:nvSpPr>
-        <p:spPr>
-          <a:xfrm>
-            <a:off x="502920" y="2148840"/>
-            <a:ext cx="1325880" cy="548640"/>
-          </a:xfrm>
-          <a:prstGeom prst="rect">
-            <a:avLst/>
-          </a:prstGeom>
-          <a:noFill/>
-        </p:spPr>
-        <p:txBody>
-          <a:bodyPr wrap="square" lIns="45720" rIns="45720" tIns="27432" bIns="27432" anchor="t">
-            <a:spAutoFit/>
-          </a:bodyPr>
-          <a:lstStyle/>
-          <a:p>
-            <a:pPr algn="ctr">
-              <a:spcAft>
-                <a:spcPts val="600"/>
-              </a:spcAft>
-            </a:pPr>
-            <a:r>
-              <a:rPr sz="1300" b="0" i="0">
-                <a:solidFill>
-                  <a:srgbClr val="595959"/>
-                </a:solidFill>
-                <a:latin typeface="Calibri"/>
-              </a:rPr>
-              <a:t>Introduction</a:t>
-            </a:r>
-          </a:p>
-        </p:txBody>
-      </p:sp>
-      <p:sp>
-        <p:nvSpPr>
-          <p:cNvPr id="8" name="Chevron 7"/>
-          <p:cNvSpPr/>
-          <p:nvPr/>
-        </p:nvSpPr>
-        <p:spPr>
-          <a:xfrm>
-            <a:off x="1901952" y="1417320"/>
-            <a:ext cx="1481328" cy="685800"/>
-          </a:xfrm>
-          <a:prstGeom prst="chevron">
-            <a:avLst/>
-          </a:prstGeom>
-          <a:solidFill>
-            <a:srgbClr val="DCDDDC"/>
-          </a:solidFill>
-          <a:ln>
-            <a:noFill/>
-          </a:ln>
-          <a:effectLst/>
-        </p:spPr>
-        <p:style>
-          <a:lnRef idx="1">
-            <a:schemeClr val="accent1"/>
-          </a:lnRef>
-          <a:fillRef idx="3">
-            <a:schemeClr val="accent1"/>
-          </a:fillRef>
-          <a:effectRef idx="2">
-            <a:schemeClr val="accent1"/>
-          </a:effectRef>
-          <a:fontRef idx="minor">
-            <a:schemeClr val="lt1"/>
-          </a:fontRef>
-        </p:style>
-        <p:txBody>
-          <a:bodyPr rtlCol="0" anchor="ctr" wrap="square" lIns="54864" rIns="54864"/>
-          <a:lstStyle/>
-          <a:p>
-            <a:pPr algn="ctr"/>
-            <a:r>
-              <a:rPr sz="1700" b="1">
-                <a:solidFill>
-                  <a:srgbClr val="595959"/>
-                </a:solidFill>
-                <a:latin typeface="Calibri"/>
-              </a:rPr>
-              <a:t>Ch 2</a:t>
-            </a:r>
-          </a:p>
-        </p:txBody>
-      </p:sp>
-      <p:sp>
-        <p:nvSpPr>
-          <p:cNvPr id="9" name="TextBox 8"/>
-          <p:cNvSpPr txBox="1"/>
-          <p:nvPr/>
-        </p:nvSpPr>
-        <p:spPr>
-          <a:xfrm>
-            <a:off x="1901952" y="2148840"/>
-            <a:ext cx="1325880" cy="548640"/>
-          </a:xfrm>
-          <a:prstGeom prst="rect">
-            <a:avLst/>
-          </a:prstGeom>
-          <a:noFill/>
-        </p:spPr>
-        <p:txBody>
-          <a:bodyPr wrap="square" lIns="45720" rIns="45720" tIns="27432" bIns="27432" anchor="t">
-            <a:spAutoFit/>
-          </a:bodyPr>
-          <a:lstStyle/>
-          <a:p>
-            <a:pPr algn="ctr">
-              <a:spcAft>
-                <a:spcPts val="600"/>
-              </a:spcAft>
-            </a:pPr>
-            <a:r>
-              <a:rPr sz="1300" b="0" i="0">
-                <a:solidFill>
-                  <a:srgbClr val="595959"/>
-                </a:solidFill>
-                <a:latin typeface="Calibri"/>
-              </a:rPr>
-              <a:t>Supervised</a:t>
-            </a:r>
-          </a:p>
-        </p:txBody>
-      </p:sp>
-      <p:sp>
-        <p:nvSpPr>
-          <p:cNvPr id="10" name="Chevron 9"/>
-          <p:cNvSpPr/>
-          <p:nvPr/>
-        </p:nvSpPr>
-        <p:spPr>
-          <a:xfrm>
-            <a:off x="3300984" y="1417320"/>
-            <a:ext cx="1481328" cy="685800"/>
-          </a:xfrm>
-          <a:prstGeom prst="chevron">
-            <a:avLst/>
-          </a:prstGeom>
-          <a:solidFill>
-            <a:srgbClr val="DCDDDC"/>
-          </a:solidFill>
-          <a:ln>
-            <a:noFill/>
-          </a:ln>
-          <a:effectLst/>
-        </p:spPr>
-        <p:style>
-          <a:lnRef idx="1">
-            <a:schemeClr val="accent1"/>
-          </a:lnRef>
-          <a:fillRef idx="3">
-            <a:schemeClr val="accent1"/>
-          </a:fillRef>
-          <a:effectRef idx="2">
-            <a:schemeClr val="accent1"/>
-          </a:effectRef>
-          <a:fontRef idx="minor">
-            <a:schemeClr val="lt1"/>
-          </a:fontRef>
-        </p:style>
-        <p:txBody>
-          <a:bodyPr rtlCol="0" anchor="ctr" wrap="square" lIns="54864" rIns="54864"/>
-          <a:lstStyle/>
-          <a:p>
-            <a:pPr algn="ctr"/>
-            <a:r>
-              <a:rPr sz="1700" b="1">
-                <a:solidFill>
-                  <a:srgbClr val="595959"/>
-                </a:solidFill>
-                <a:latin typeface="Calibri"/>
-              </a:rPr>
-              <a:t>Ch 3</a:t>
-            </a:r>
-          </a:p>
-        </p:txBody>
-      </p:sp>
-      <p:sp>
-        <p:nvSpPr>
-          <p:cNvPr id="11" name="TextBox 10"/>
-          <p:cNvSpPr txBox="1"/>
-          <p:nvPr/>
-        </p:nvSpPr>
-        <p:spPr>
-          <a:xfrm>
-            <a:off x="3300984" y="2148840"/>
-            <a:ext cx="1325880" cy="548640"/>
-          </a:xfrm>
-          <a:prstGeom prst="rect">
-            <a:avLst/>
-          </a:prstGeom>
-          <a:noFill/>
-        </p:spPr>
-        <p:txBody>
-          <a:bodyPr wrap="square" lIns="45720" rIns="45720" tIns="27432" bIns="27432" anchor="t">
-            <a:spAutoFit/>
-          </a:bodyPr>
-          <a:lstStyle/>
-          <a:p>
-            <a:pPr algn="ctr">
-              <a:spcAft>
-                <a:spcPts val="600"/>
-              </a:spcAft>
-            </a:pPr>
-            <a:r>
-              <a:rPr sz="1300" b="0" i="0">
-                <a:solidFill>
-                  <a:srgbClr val="595959"/>
-                </a:solidFill>
-                <a:latin typeface="Calibri"/>
-              </a:rPr>
-              <a:t>Shallow nets</a:t>
-            </a:r>
-          </a:p>
-        </p:txBody>
-      </p:sp>
-      <p:sp>
-        <p:nvSpPr>
-          <p:cNvPr id="12" name="Chevron 11"/>
-          <p:cNvSpPr/>
-          <p:nvPr/>
-        </p:nvSpPr>
-        <p:spPr>
-          <a:xfrm>
-            <a:off x="4700016" y="1417320"/>
-            <a:ext cx="1481328" cy="685800"/>
-          </a:xfrm>
-          <a:prstGeom prst="chevron">
-            <a:avLst/>
-          </a:prstGeom>
-          <a:solidFill>
-            <a:srgbClr val="DCDDDC"/>
-          </a:solidFill>
-          <a:ln>
-            <a:noFill/>
-          </a:ln>
-          <a:effectLst/>
-        </p:spPr>
-        <p:style>
-          <a:lnRef idx="1">
-            <a:schemeClr val="accent1"/>
-          </a:lnRef>
-          <a:fillRef idx="3">
-            <a:schemeClr val="accent1"/>
-          </a:fillRef>
-          <a:effectRef idx="2">
-            <a:schemeClr val="accent1"/>
-          </a:effectRef>
-          <a:fontRef idx="minor">
-            <a:schemeClr val="lt1"/>
-          </a:fontRef>
-        </p:style>
-        <p:txBody>
-          <a:bodyPr rtlCol="0" anchor="ctr" wrap="square" lIns="54864" rIns="54864"/>
-          <a:lstStyle/>
-          <a:p>
-            <a:pPr algn="ctr"/>
-            <a:r>
-              <a:rPr sz="1700" b="1">
-                <a:solidFill>
-                  <a:srgbClr val="595959"/>
-                </a:solidFill>
-                <a:latin typeface="Calibri"/>
-              </a:rPr>
-              <a:t>Ch 4</a:t>
-            </a:r>
-          </a:p>
-        </p:txBody>
-      </p:sp>
-      <p:sp>
-        <p:nvSpPr>
-          <p:cNvPr id="13" name="TextBox 12"/>
-          <p:cNvSpPr txBox="1"/>
-          <p:nvPr/>
-        </p:nvSpPr>
-        <p:spPr>
-          <a:xfrm>
-            <a:off x="4700016" y="2148840"/>
-            <a:ext cx="1325880" cy="548640"/>
-          </a:xfrm>
-          <a:prstGeom prst="rect">
-            <a:avLst/>
-          </a:prstGeom>
-          <a:noFill/>
-        </p:spPr>
-        <p:txBody>
-          <a:bodyPr wrap="square" lIns="45720" rIns="45720" tIns="27432" bIns="27432" anchor="t">
-            <a:spAutoFit/>
-          </a:bodyPr>
-          <a:lstStyle/>
-          <a:p>
-            <a:pPr algn="ctr">
-              <a:spcAft>
-                <a:spcPts val="600"/>
-              </a:spcAft>
-            </a:pPr>
-            <a:r>
-              <a:rPr sz="1300" b="0" i="0">
-                <a:solidFill>
-                  <a:srgbClr val="595959"/>
-                </a:solidFill>
-                <a:latin typeface="Calibri"/>
-              </a:rPr>
-              <a:t>Deep nets</a:t>
-            </a:r>
-          </a:p>
-        </p:txBody>
-      </p:sp>
-      <p:sp>
-        <p:nvSpPr>
-          <p:cNvPr id="14" name="Chevron 13"/>
-          <p:cNvSpPr/>
-          <p:nvPr/>
-        </p:nvSpPr>
-        <p:spPr>
-          <a:xfrm>
-            <a:off x="6099048" y="1417320"/>
-            <a:ext cx="1481328" cy="685800"/>
-          </a:xfrm>
-          <a:prstGeom prst="chevron">
-            <a:avLst/>
-          </a:prstGeom>
-          <a:solidFill>
-            <a:srgbClr val="008759"/>
-          </a:solidFill>
-          <a:ln>
-            <a:noFill/>
-          </a:ln>
-          <a:effectLst/>
-        </p:spPr>
-        <p:style>
-          <a:lnRef idx="1">
-            <a:schemeClr val="accent1"/>
-          </a:lnRef>
-          <a:fillRef idx="3">
-            <a:schemeClr val="accent1"/>
-          </a:fillRef>
-          <a:effectRef idx="2">
-            <a:schemeClr val="accent1"/>
-          </a:effectRef>
-          <a:fontRef idx="minor">
-            <a:schemeClr val="lt1"/>
-          </a:fontRef>
-        </p:style>
-        <p:txBody>
-          <a:bodyPr rtlCol="0" anchor="ctr" wrap="square" lIns="54864" rIns="54864"/>
-          <a:lstStyle/>
-          <a:p>
-            <a:pPr algn="ctr"/>
-            <a:r>
-              <a:rPr sz="1700" b="1">
-                <a:solidFill>
-                  <a:srgbClr val="FFFFFF"/>
-                </a:solidFill>
-                <a:latin typeface="Calibri"/>
-              </a:rPr>
-              <a:t>Ch 5</a:t>
-            </a:r>
-          </a:p>
-        </p:txBody>
-      </p:sp>
-      <p:sp>
-        <p:nvSpPr>
-          <p:cNvPr id="15" name="TextBox 14"/>
-          <p:cNvSpPr txBox="1"/>
-          <p:nvPr/>
-        </p:nvSpPr>
-        <p:spPr>
-          <a:xfrm>
-            <a:off x="6099048" y="2148840"/>
-            <a:ext cx="1325880" cy="548640"/>
-          </a:xfrm>
-          <a:prstGeom prst="rect">
-            <a:avLst/>
-          </a:prstGeom>
-          <a:noFill/>
-        </p:spPr>
-        <p:txBody>
-          <a:bodyPr wrap="square" lIns="45720" rIns="45720" tIns="27432" bIns="27432" anchor="t">
-            <a:spAutoFit/>
-          </a:bodyPr>
-          <a:lstStyle/>
-          <a:p>
-            <a:pPr algn="ctr">
-              <a:spcAft>
-                <a:spcPts val="600"/>
-              </a:spcAft>
-            </a:pPr>
-            <a:r>
-              <a:rPr sz="1300" b="1" i="0">
-                <a:solidFill>
-                  <a:srgbClr val="404040"/>
-                </a:solidFill>
-                <a:latin typeface="Calibri"/>
-              </a:rPr>
-              <a:t>Loss functions</a:t>
-            </a:r>
-          </a:p>
-        </p:txBody>
-      </p:sp>
-      <p:sp>
-        <p:nvSpPr>
-          <p:cNvPr id="16" name="Chevron 15"/>
-          <p:cNvSpPr/>
-          <p:nvPr/>
-        </p:nvSpPr>
-        <p:spPr>
-          <a:xfrm>
-            <a:off x="7498080" y="1417320"/>
-            <a:ext cx="1481328" cy="685800"/>
-          </a:xfrm>
-          <a:prstGeom prst="chevron">
-            <a:avLst/>
-          </a:prstGeom>
-          <a:solidFill>
-            <a:srgbClr val="008759"/>
-          </a:solidFill>
-          <a:ln>
-            <a:noFill/>
-          </a:ln>
-          <a:effectLst/>
-        </p:spPr>
-        <p:style>
-          <a:lnRef idx="1">
-            <a:schemeClr val="accent1"/>
-          </a:lnRef>
-          <a:fillRef idx="3">
-            <a:schemeClr val="accent1"/>
-          </a:fillRef>
-          <a:effectRef idx="2">
-            <a:schemeClr val="accent1"/>
-          </a:effectRef>
-          <a:fontRef idx="minor">
-            <a:schemeClr val="lt1"/>
-          </a:fontRef>
-        </p:style>
-        <p:txBody>
-          <a:bodyPr rtlCol="0" anchor="ctr" wrap="square" lIns="54864" rIns="54864"/>
-          <a:lstStyle/>
-          <a:p>
-            <a:pPr algn="ctr"/>
-            <a:r>
-              <a:rPr sz="1700" b="1">
-                <a:solidFill>
-                  <a:srgbClr val="FFFFFF"/>
-                </a:solidFill>
-                <a:latin typeface="Calibri"/>
-              </a:rPr>
-              <a:t>Ch 6</a:t>
-            </a:r>
-          </a:p>
-        </p:txBody>
-      </p:sp>
-      <p:sp>
-        <p:nvSpPr>
-          <p:cNvPr id="17" name="TextBox 16"/>
-          <p:cNvSpPr txBox="1"/>
-          <p:nvPr/>
-        </p:nvSpPr>
-        <p:spPr>
-          <a:xfrm>
-            <a:off x="7498080" y="2148840"/>
-            <a:ext cx="1325880" cy="548640"/>
-          </a:xfrm>
-          <a:prstGeom prst="rect">
-            <a:avLst/>
-          </a:prstGeom>
-          <a:noFill/>
-        </p:spPr>
-        <p:txBody>
-          <a:bodyPr wrap="square" lIns="45720" rIns="45720" tIns="27432" bIns="27432" anchor="t">
-            <a:spAutoFit/>
-          </a:bodyPr>
-          <a:lstStyle/>
-          <a:p>
-            <a:pPr algn="ctr">
-              <a:spcAft>
-                <a:spcPts val="600"/>
-              </a:spcAft>
-            </a:pPr>
-            <a:r>
-              <a:rPr sz="1300" b="1" i="0">
-                <a:solidFill>
-                  <a:srgbClr val="404040"/>
-                </a:solidFill>
-                <a:latin typeface="Calibri"/>
-              </a:rPr>
-              <a:t>Fitting</a:t>
-            </a:r>
-          </a:p>
-        </p:txBody>
-      </p:sp>
-      <p:sp>
-        <p:nvSpPr>
-          <p:cNvPr id="18" name="Chevron 17"/>
-          <p:cNvSpPr/>
-          <p:nvPr/>
-        </p:nvSpPr>
-        <p:spPr>
-          <a:xfrm>
-            <a:off x="8897112" y="1417320"/>
-            <a:ext cx="1481328" cy="685800"/>
-          </a:xfrm>
-          <a:prstGeom prst="chevron">
-            <a:avLst/>
-          </a:prstGeom>
-          <a:solidFill>
-            <a:srgbClr val="DCDDDC"/>
-          </a:solidFill>
-          <a:ln>
-            <a:noFill/>
-          </a:ln>
-          <a:effectLst/>
-        </p:spPr>
-        <p:style>
-          <a:lnRef idx="1">
-            <a:schemeClr val="accent1"/>
-          </a:lnRef>
-          <a:fillRef idx="3">
-            <a:schemeClr val="accent1"/>
-          </a:fillRef>
-          <a:effectRef idx="2">
-            <a:schemeClr val="accent1"/>
-          </a:effectRef>
-          <a:fontRef idx="minor">
-            <a:schemeClr val="lt1"/>
-          </a:fontRef>
-        </p:style>
-        <p:txBody>
-          <a:bodyPr rtlCol="0" anchor="ctr" wrap="square" lIns="54864" rIns="54864"/>
-          <a:lstStyle/>
-          <a:p>
-            <a:pPr algn="ctr"/>
-            <a:r>
-              <a:rPr sz="1700" b="1">
-                <a:solidFill>
-                  <a:srgbClr val="595959"/>
-                </a:solidFill>
-                <a:latin typeface="Calibri"/>
-              </a:rPr>
-              <a:t>Ch 7</a:t>
-            </a:r>
-          </a:p>
-        </p:txBody>
-      </p:sp>
-      <p:sp>
-        <p:nvSpPr>
-          <p:cNvPr id="19" name="TextBox 18"/>
-          <p:cNvSpPr txBox="1"/>
-          <p:nvPr/>
-        </p:nvSpPr>
-        <p:spPr>
-          <a:xfrm>
-            <a:off x="8897112" y="2148840"/>
-            <a:ext cx="1325880" cy="548640"/>
-          </a:xfrm>
-          <a:prstGeom prst="rect">
-            <a:avLst/>
-          </a:prstGeom>
-          <a:noFill/>
-        </p:spPr>
-        <p:txBody>
-          <a:bodyPr wrap="square" lIns="45720" rIns="45720" tIns="27432" bIns="27432" anchor="t">
-            <a:spAutoFit/>
-          </a:bodyPr>
-          <a:lstStyle/>
-          <a:p>
-            <a:pPr algn="ctr">
-              <a:spcAft>
-                <a:spcPts val="600"/>
-              </a:spcAft>
-            </a:pPr>
-            <a:r>
-              <a:rPr sz="1300" b="0" i="0">
-                <a:solidFill>
-                  <a:srgbClr val="595959"/>
-                </a:solidFill>
-                <a:latin typeface="Calibri"/>
-              </a:rPr>
-              <a:t>Gradients &amp; init</a:t>
-            </a:r>
-          </a:p>
-        </p:txBody>
-      </p:sp>
-      <p:sp>
-        <p:nvSpPr>
-          <p:cNvPr id="20" name="Chevron 19"/>
-          <p:cNvSpPr/>
-          <p:nvPr/>
-        </p:nvSpPr>
-        <p:spPr>
-          <a:xfrm>
-            <a:off x="10296144" y="1417320"/>
-            <a:ext cx="1481328" cy="685800"/>
-          </a:xfrm>
-          <a:prstGeom prst="chevron">
-            <a:avLst/>
-          </a:prstGeom>
-          <a:solidFill>
-            <a:srgbClr val="DCDDDC"/>
-          </a:solidFill>
-          <a:ln>
-            <a:noFill/>
-          </a:ln>
-          <a:effectLst/>
-        </p:spPr>
-        <p:style>
-          <a:lnRef idx="1">
-            <a:schemeClr val="accent1"/>
-          </a:lnRef>
-          <a:fillRef idx="3">
-            <a:schemeClr val="accent1"/>
-          </a:fillRef>
-          <a:effectRef idx="2">
-            <a:schemeClr val="accent1"/>
-          </a:effectRef>
-          <a:fontRef idx="minor">
-            <a:schemeClr val="lt1"/>
-          </a:fontRef>
-        </p:style>
-        <p:txBody>
-          <a:bodyPr rtlCol="0" anchor="ctr" wrap="square" lIns="54864" rIns="54864"/>
-          <a:lstStyle/>
-          <a:p>
-            <a:pPr algn="ctr"/>
-            <a:r>
-              <a:rPr sz="1700" b="1">
-                <a:solidFill>
-                  <a:srgbClr val="595959"/>
-                </a:solidFill>
-                <a:latin typeface="Calibri"/>
-              </a:rPr>
-              <a:t>Ch 8</a:t>
-            </a:r>
-          </a:p>
-        </p:txBody>
-      </p:sp>
-      <p:sp>
-        <p:nvSpPr>
-          <p:cNvPr id="21" name="TextBox 20"/>
-          <p:cNvSpPr txBox="1"/>
-          <p:nvPr/>
-        </p:nvSpPr>
-        <p:spPr>
-          <a:xfrm>
-            <a:off x="10296144" y="2148840"/>
-            <a:ext cx="1325880" cy="548640"/>
-          </a:xfrm>
-          <a:prstGeom prst="rect">
-            <a:avLst/>
-          </a:prstGeom>
-          <a:noFill/>
-        </p:spPr>
-        <p:txBody>
-          <a:bodyPr wrap="square" lIns="45720" rIns="45720" tIns="27432" bIns="27432" anchor="t">
-            <a:spAutoFit/>
-          </a:bodyPr>
-          <a:lstStyle/>
-          <a:p>
-            <a:pPr algn="ctr">
-              <a:spcAft>
-                <a:spcPts val="600"/>
-              </a:spcAft>
-            </a:pPr>
-            <a:r>
-              <a:rPr sz="1300" b="0" i="0">
-                <a:solidFill>
-                  <a:srgbClr val="595959"/>
-                </a:solidFill>
-                <a:latin typeface="Calibri"/>
-              </a:rPr>
-              <a:t>Performance</a:t>
-            </a:r>
-          </a:p>
-        </p:txBody>
-      </p:sp>
-      <p:sp>
-        <p:nvSpPr>
-          <p:cNvPr id="22" name="Rounded Rectangle 21"/>
-          <p:cNvSpPr/>
-          <p:nvPr/>
-        </p:nvSpPr>
-        <p:spPr>
-          <a:xfrm>
-            <a:off x="502920" y="2834640"/>
-            <a:ext cx="3566160" cy="2377440"/>
-          </a:xfrm>
-          <a:prstGeom prst="roundRect">
-            <a:avLst>
-              <a:gd name="adj" fmla="val 4000"/>
-            </a:avLst>
-          </a:prstGeom>
-          <a:solidFill>
-            <a:srgbClr val="F7F7F7"/>
-          </a:solidFill>
-          <a:ln w="15875">
-            <a:solidFill>
-              <a:srgbClr val="DCDDDC"/>
-            </a:solidFill>
-          </a:ln>
-          <a:effectLst/>
-        </p:spPr>
-        <p:style>
-          <a:lnRef idx="1">
-            <a:schemeClr val="accent1"/>
-          </a:lnRef>
-          <a:fillRef idx="3">
-            <a:schemeClr val="accent1"/>
-          </a:fillRef>
-          <a:effectRef idx="2">
-            <a:schemeClr val="accent1"/>
-          </a:effectRef>
-          <a:fontRef idx="minor">
-            <a:schemeClr val="lt1"/>
-          </a:fontRef>
-        </p:style>
-        <p:txBody>
-          <a:bodyPr rtlCol="0" anchor="ctr"/>
-          <a:lstStyle/>
-          <a:p>
-            <a:pPr algn="ctr"/>
-          </a:p>
-        </p:txBody>
-      </p:sp>
-      <p:sp>
-        <p:nvSpPr>
-          <p:cNvPr id="23" name="Rounded Rectangle 22"/>
-          <p:cNvSpPr/>
-          <p:nvPr/>
-        </p:nvSpPr>
-        <p:spPr>
-          <a:xfrm>
-            <a:off x="640080" y="2971800"/>
-            <a:ext cx="3291840" cy="310896"/>
-          </a:xfrm>
-          <a:prstGeom prst="roundRect">
-            <a:avLst>
-              <a:gd name="adj" fmla="val 25000"/>
-            </a:avLst>
-          </a:prstGeom>
-          <a:solidFill>
-            <a:srgbClr val="B0B0B0"/>
-          </a:solidFill>
-          <a:ln>
-            <a:noFill/>
-          </a:ln>
-          <a:effectLst/>
-        </p:spPr>
-        <p:style>
-          <a:lnRef idx="1">
-            <a:schemeClr val="accent1"/>
-          </a:lnRef>
-          <a:fillRef idx="3">
-            <a:schemeClr val="accent1"/>
-          </a:fillRef>
-          <a:effectRef idx="2">
-            <a:schemeClr val="accent1"/>
-          </a:effectRef>
-          <a:fontRef idx="minor">
-            <a:schemeClr val="lt1"/>
-          </a:fontRef>
-        </p:style>
-        <p:txBody>
-          <a:bodyPr rtlCol="0" anchor="ctr" tIns="9144" bIns="9144"/>
-          <a:lstStyle/>
-          <a:p>
-            <a:pPr algn="ctr"/>
-            <a:r>
-              <a:rPr sz="1200" b="1">
-                <a:solidFill>
-                  <a:srgbClr val="FFFFFF"/>
-                </a:solidFill>
-                <a:latin typeface="Calibri"/>
-              </a:rPr>
-              <a:t>SESSION 1</a:t>
-            </a:r>
-          </a:p>
-        </p:txBody>
-      </p:sp>
-      <p:sp>
-        <p:nvSpPr>
-          <p:cNvPr id="24" name="TextBox 23"/>
-          <p:cNvSpPr txBox="1"/>
-          <p:nvPr/>
-        </p:nvSpPr>
-        <p:spPr>
-          <a:xfrm>
-            <a:off x="640080" y="3429000"/>
-            <a:ext cx="3291840" cy="1005840"/>
-          </a:xfrm>
-          <a:prstGeom prst="rect">
-            <a:avLst/>
-          </a:prstGeom>
-          <a:noFill/>
-        </p:spPr>
-        <p:txBody>
-          <a:bodyPr wrap="square" lIns="45720" rIns="45720" tIns="27432" bIns="27432" anchor="t">
-            <a:spAutoFit/>
-          </a:bodyPr>
-          <a:lstStyle/>
-          <a:p>
-            <a:pPr algn="l">
-              <a:spcAft>
-                <a:spcPts val="600"/>
-              </a:spcAft>
-            </a:pPr>
-            <a:r>
-              <a:rPr sz="1500" b="0" i="0">
-                <a:solidFill>
-                  <a:srgbClr val="595959"/>
-                </a:solidFill>
-                <a:latin typeface="Calibri"/>
-              </a:rPr>
-              <a:t>Models. What function? y = f[x, ϕ]: lines, then ReLU nets that fold space</a:t>
-            </a:r>
-          </a:p>
-        </p:txBody>
-      </p:sp>
-      <p:sp>
-        <p:nvSpPr>
-          <p:cNvPr id="25" name="TextBox 24"/>
-          <p:cNvSpPr txBox="1"/>
-          <p:nvPr/>
-        </p:nvSpPr>
-        <p:spPr>
-          <a:xfrm>
-            <a:off x="640080" y="4480560"/>
-            <a:ext cx="3291840" cy="640080"/>
-          </a:xfrm>
-          <a:prstGeom prst="rect">
-            <a:avLst/>
-          </a:prstGeom>
-          <a:noFill/>
-        </p:spPr>
-        <p:txBody>
-          <a:bodyPr wrap="square" lIns="45720" rIns="45720" tIns="27432" bIns="27432" anchor="t">
-            <a:spAutoFit/>
-          </a:bodyPr>
-          <a:lstStyle/>
-          <a:p>
-            <a:pPr algn="l">
-              <a:spcAft>
-                <a:spcPts val="600"/>
-              </a:spcAft>
-            </a:pPr>
-            <a:r>
-              <a:rPr sz="1300" b="0" i="1">
-                <a:solidFill>
-                  <a:srgbClr val="595959"/>
-                </a:solidFill>
-                <a:latin typeface="Calibri"/>
-              </a:rPr>
-              <a:t>Pup weigh-in · burrows · dune sea</a:t>
-            </a:r>
-          </a:p>
-        </p:txBody>
-      </p:sp>
-      <p:sp>
-        <p:nvSpPr>
-          <p:cNvPr id="26" name="Rounded Rectangle 25"/>
-          <p:cNvSpPr/>
-          <p:nvPr/>
-        </p:nvSpPr>
-        <p:spPr>
-          <a:xfrm>
-            <a:off x="4251959" y="2834640"/>
-            <a:ext cx="3566160" cy="2377440"/>
-          </a:xfrm>
-          <a:prstGeom prst="roundRect">
-            <a:avLst>
-              <a:gd name="adj" fmla="val 4000"/>
-            </a:avLst>
-          </a:prstGeom>
-          <a:solidFill>
-            <a:srgbClr val="FFFFFF"/>
-          </a:solidFill>
-          <a:ln w="15875">
-            <a:solidFill>
-              <a:srgbClr val="008759"/>
-            </a:solidFill>
-          </a:ln>
-          <a:effectLst/>
-        </p:spPr>
-        <p:style>
-          <a:lnRef idx="1">
-            <a:schemeClr val="accent1"/>
-          </a:lnRef>
-          <a:fillRef idx="3">
-            <a:schemeClr val="accent1"/>
-          </a:fillRef>
-          <a:effectRef idx="2">
-            <a:schemeClr val="accent1"/>
-          </a:effectRef>
-          <a:fontRef idx="minor">
-            <a:schemeClr val="lt1"/>
-          </a:fontRef>
-        </p:style>
-        <p:txBody>
-          <a:bodyPr rtlCol="0" anchor="ctr"/>
-          <a:lstStyle/>
-          <a:p>
-            <a:pPr algn="ctr"/>
-          </a:p>
-        </p:txBody>
-      </p:sp>
-      <p:sp>
-        <p:nvSpPr>
-          <p:cNvPr id="27" name="Rounded Rectangle 26"/>
-          <p:cNvSpPr/>
-          <p:nvPr/>
-        </p:nvSpPr>
-        <p:spPr>
-          <a:xfrm>
-            <a:off x="4389120" y="2971800"/>
-            <a:ext cx="3291840" cy="310896"/>
-          </a:xfrm>
-          <a:prstGeom prst="roundRect">
-            <a:avLst>
-              <a:gd name="adj" fmla="val 25000"/>
-            </a:avLst>
-          </a:prstGeom>
-          <a:solidFill>
-            <a:srgbClr val="008759"/>
-          </a:solidFill>
-          <a:ln>
-            <a:noFill/>
-          </a:ln>
-          <a:effectLst/>
-        </p:spPr>
-        <p:style>
-          <a:lnRef idx="1">
-            <a:schemeClr val="accent1"/>
-          </a:lnRef>
-          <a:fillRef idx="3">
-            <a:schemeClr val="accent1"/>
-          </a:fillRef>
-          <a:effectRef idx="2">
-            <a:schemeClr val="accent1"/>
-          </a:effectRef>
-          <a:fontRef idx="minor">
-            <a:schemeClr val="lt1"/>
-          </a:fontRef>
-        </p:style>
-        <p:txBody>
-          <a:bodyPr rtlCol="0" anchor="ctr" tIns="9144" bIns="9144"/>
-          <a:lstStyle/>
-          <a:p>
-            <a:pPr algn="ctr"/>
-            <a:r>
-              <a:rPr sz="1200" b="1">
-                <a:solidFill>
-                  <a:srgbClr val="FFFFFF"/>
-                </a:solidFill>
-                <a:latin typeface="Calibri"/>
-              </a:rPr>
-              <a:t>SESSION 2</a:t>
-            </a:r>
-          </a:p>
-        </p:txBody>
-      </p:sp>
-      <p:sp>
-        <p:nvSpPr>
-          <p:cNvPr id="28" name="TextBox 27"/>
-          <p:cNvSpPr txBox="1"/>
-          <p:nvPr/>
-        </p:nvSpPr>
-        <p:spPr>
-          <a:xfrm>
-            <a:off x="4389120" y="3429000"/>
-            <a:ext cx="3291840" cy="1005840"/>
-          </a:xfrm>
-          <a:prstGeom prst="rect">
-            <a:avLst/>
-          </a:prstGeom>
-          <a:noFill/>
-        </p:spPr>
-        <p:txBody>
-          <a:bodyPr wrap="square" lIns="45720" rIns="45720" tIns="27432" bIns="27432" anchor="t">
-            <a:spAutoFit/>
-          </a:bodyPr>
-          <a:lstStyle/>
-          <a:p>
-            <a:pPr algn="l">
-              <a:spcAft>
-                <a:spcPts val="600"/>
-              </a:spcAft>
-            </a:pPr>
-            <a:r>
-              <a:rPr sz="1500" b="0" i="0">
-                <a:solidFill>
-                  <a:srgbClr val="404040"/>
-                </a:solidFill>
-                <a:latin typeface="Calibri"/>
-              </a:rPr>
-              <a:t>Losses and training. What is 'good', and how do we find it? Likelihood; GD, SGD, Adam</a:t>
-            </a:r>
-          </a:p>
-        </p:txBody>
-      </p:sp>
-      <p:sp>
-        <p:nvSpPr>
-          <p:cNvPr id="29" name="TextBox 28"/>
-          <p:cNvSpPr txBox="1"/>
-          <p:nvPr/>
-        </p:nvSpPr>
-        <p:spPr>
-          <a:xfrm>
-            <a:off x="4389120" y="4480560"/>
-            <a:ext cx="3291840" cy="640080"/>
-          </a:xfrm>
-          <a:prstGeom prst="rect">
-            <a:avLst/>
-          </a:prstGeom>
-          <a:noFill/>
-        </p:spPr>
-        <p:txBody>
-          <a:bodyPr wrap="square" lIns="45720" rIns="45720" tIns="27432" bIns="27432" anchor="t">
-            <a:spAutoFit/>
-          </a:bodyPr>
-          <a:lstStyle/>
-          <a:p>
-            <a:pPr algn="l">
-              <a:spcAft>
-                <a:spcPts val="600"/>
-              </a:spcAft>
-            </a:pPr>
-            <a:r>
-              <a:rPr sz="1300" b="0" i="1">
-                <a:solidFill>
-                  <a:srgbClr val="595959"/>
-                </a:solidFill>
-                <a:latin typeface="Calibri"/>
-              </a:rPr>
-              <a:t>Alarm calls · scorpions · race to the burrow</a:t>
-            </a:r>
-          </a:p>
-        </p:txBody>
-      </p:sp>
-      <p:sp>
-        <p:nvSpPr>
-          <p:cNvPr id="30" name="Rounded Rectangle 29"/>
-          <p:cNvSpPr/>
-          <p:nvPr/>
-        </p:nvSpPr>
-        <p:spPr>
-          <a:xfrm>
-            <a:off x="6766559" y="2606040"/>
-            <a:ext cx="914400" cy="329184"/>
-          </a:xfrm>
-          <a:prstGeom prst="roundRect">
-            <a:avLst/>
-          </a:prstGeom>
-          <a:solidFill>
-            <a:srgbClr val="CF1D10"/>
-          </a:solidFill>
-          <a:ln>
-            <a:noFill/>
-          </a:ln>
-          <a:effectLst/>
-        </p:spPr>
-        <p:style>
-          <a:lnRef idx="1">
-            <a:schemeClr val="accent1"/>
-          </a:lnRef>
-          <a:fillRef idx="3">
-            <a:schemeClr val="accent1"/>
-          </a:fillRef>
-          <a:effectRef idx="2">
-            <a:schemeClr val="accent1"/>
-          </a:effectRef>
-          <a:fontRef idx="minor">
-            <a:schemeClr val="lt1"/>
-          </a:fontRef>
-        </p:style>
-        <p:txBody>
-          <a:bodyPr rtlCol="0" anchor="ctr" wrap="square" lIns="54864" rIns="54864"/>
-          <a:lstStyle/>
-          <a:p>
-            <a:pPr algn="ctr"/>
-            <a:r>
-              <a:rPr sz="1200" b="1">
-                <a:solidFill>
-                  <a:srgbClr val="FFFFFF"/>
-                </a:solidFill>
-                <a:latin typeface="Calibri"/>
-              </a:rPr>
-              <a:t>TODAY</a:t>
-            </a:r>
-          </a:p>
-        </p:txBody>
-      </p:sp>
-      <p:sp>
-        <p:nvSpPr>
-          <p:cNvPr id="31" name="Rounded Rectangle 30"/>
-          <p:cNvSpPr/>
-          <p:nvPr/>
-        </p:nvSpPr>
-        <p:spPr>
-          <a:xfrm>
-            <a:off x="8001000" y="2834640"/>
-            <a:ext cx="3566160" cy="2377440"/>
-          </a:xfrm>
-          <a:prstGeom prst="roundRect">
-            <a:avLst>
-              <a:gd name="adj" fmla="val 4000"/>
-            </a:avLst>
-          </a:prstGeom>
-          <a:solidFill>
-            <a:srgbClr val="F7F7F7"/>
-          </a:solidFill>
-          <a:ln w="15875">
-            <a:solidFill>
-              <a:srgbClr val="DCDDDC"/>
-            </a:solidFill>
-          </a:ln>
-          <a:effectLst/>
-        </p:spPr>
-        <p:style>
-          <a:lnRef idx="1">
-            <a:schemeClr val="accent1"/>
-          </a:lnRef>
-          <a:fillRef idx="3">
-            <a:schemeClr val="accent1"/>
-          </a:fillRef>
-          <a:effectRef idx="2">
-            <a:schemeClr val="accent1"/>
-          </a:effectRef>
-          <a:fontRef idx="minor">
-            <a:schemeClr val="lt1"/>
-          </a:fontRef>
-        </p:style>
-        <p:txBody>
-          <a:bodyPr rtlCol="0" anchor="ctr"/>
-          <a:lstStyle/>
-          <a:p>
-            <a:pPr algn="ctr"/>
-          </a:p>
-        </p:txBody>
-      </p:sp>
-      <p:sp>
-        <p:nvSpPr>
-          <p:cNvPr id="32" name="Rounded Rectangle 31"/>
-          <p:cNvSpPr/>
-          <p:nvPr/>
-        </p:nvSpPr>
-        <p:spPr>
-          <a:xfrm>
-            <a:off x="8138160" y="2971800"/>
-            <a:ext cx="3291840" cy="310896"/>
-          </a:xfrm>
-          <a:prstGeom prst="roundRect">
-            <a:avLst>
-              <a:gd name="adj" fmla="val 25000"/>
-            </a:avLst>
-          </a:prstGeom>
-          <a:solidFill>
-            <a:srgbClr val="B0B0B0"/>
-          </a:solidFill>
-          <a:ln>
-            <a:noFill/>
-          </a:ln>
-          <a:effectLst/>
-        </p:spPr>
-        <p:style>
-          <a:lnRef idx="1">
-            <a:schemeClr val="accent1"/>
-          </a:lnRef>
-          <a:fillRef idx="3">
-            <a:schemeClr val="accent1"/>
-          </a:fillRef>
-          <a:effectRef idx="2">
-            <a:schemeClr val="accent1"/>
-          </a:effectRef>
-          <a:fontRef idx="minor">
-            <a:schemeClr val="lt1"/>
-          </a:fontRef>
-        </p:style>
-        <p:txBody>
-          <a:bodyPr rtlCol="0" anchor="ctr" tIns="9144" bIns="9144"/>
-          <a:lstStyle/>
-          <a:p>
-            <a:pPr algn="ctr"/>
-            <a:r>
-              <a:rPr sz="1200" b="1">
-                <a:solidFill>
-                  <a:srgbClr val="FFFFFF"/>
-                </a:solidFill>
-                <a:latin typeface="Calibri"/>
-              </a:rPr>
-              <a:t>SESSION 3</a:t>
-            </a:r>
-          </a:p>
-        </p:txBody>
-      </p:sp>
-      <p:sp>
-        <p:nvSpPr>
-          <p:cNvPr id="33" name="TextBox 32"/>
-          <p:cNvSpPr txBox="1"/>
-          <p:nvPr/>
-        </p:nvSpPr>
-        <p:spPr>
-          <a:xfrm>
-            <a:off x="8138160" y="3429000"/>
-            <a:ext cx="3291840" cy="1005840"/>
-          </a:xfrm>
-          <a:prstGeom prst="rect">
-            <a:avLst/>
-          </a:prstGeom>
-          <a:noFill/>
-        </p:spPr>
-        <p:txBody>
-          <a:bodyPr wrap="square" lIns="45720" rIns="45720" tIns="27432" bIns="27432" anchor="t">
-            <a:spAutoFit/>
-          </a:bodyPr>
-          <a:lstStyle/>
-          <a:p>
-            <a:pPr algn="l">
-              <a:spcAft>
-                <a:spcPts val="600"/>
-              </a:spcAft>
-            </a:pPr>
-            <a:r>
-              <a:rPr sz="1500" b="0" i="0">
-                <a:solidFill>
-                  <a:srgbClr val="595959"/>
-                </a:solidFill>
-                <a:latin typeface="Calibri"/>
-              </a:rPr>
-              <a:t>Backprop and performance. Gradients at scale, initialisation, and does it generalise?</a:t>
-            </a:r>
-          </a:p>
-        </p:txBody>
-      </p:sp>
-      <p:sp>
-        <p:nvSpPr>
-          <p:cNvPr id="34" name="TextBox 33"/>
-          <p:cNvSpPr txBox="1"/>
-          <p:nvPr/>
-        </p:nvSpPr>
-        <p:spPr>
-          <a:xfrm>
-            <a:off x="8138160" y="4480560"/>
-            <a:ext cx="3291840" cy="640080"/>
-          </a:xfrm>
-          <a:prstGeom prst="rect">
-            <a:avLst/>
-          </a:prstGeom>
-          <a:noFill/>
-        </p:spPr>
-        <p:txBody>
-          <a:bodyPr wrap="square" lIns="45720" rIns="45720" tIns="27432" bIns="27432" anchor="t">
-            <a:spAutoFit/>
-          </a:bodyPr>
-          <a:lstStyle/>
-          <a:p>
-            <a:pPr algn="l">
-              <a:spcAft>
-                <a:spcPts val="600"/>
-              </a:spcAft>
-            </a:pPr>
-            <a:r>
-              <a:rPr sz="1300" b="0" i="1">
-                <a:solidFill>
-                  <a:srgbClr val="595959"/>
-                </a:solidFill>
-                <a:latin typeface="Calibri"/>
-              </a:rPr>
-              <a:t>Backprop by hand · call classifier · condensates</a:t>
-            </a:r>
-          </a:p>
-        </p:txBody>
-      </p:sp>
-    </p:spTree>
-  </p:cSld>
-  <p:clrMapOvr>
-    <a:masterClrMapping/>
-  </p:clrMapOvr>
-</p:sld>
-</file>
-
-<file path=ppt/slides/slide4.xml><?xml version="1.0" encoding="utf-8"?>
 <p:sld xmlns:a="http://schemas.openxmlformats.org/drawingml/2006/main" xmlns:p="http://schemas.openxmlformats.org/presentationml/2006/main" xmlns:r="http://schemas.openxmlformats.org/officeDocument/2006/relationships">
   <p:cSld>
     <p:spTree>
@@ -7558,7 +5428,7 @@
 </p:sld>
 </file>
 
-<file path=ppt/slides/slide5.xml><?xml version="1.0" encoding="utf-8"?>
+<file path=ppt/slides/slide4.xml><?xml version="1.0" encoding="utf-8"?>
 <p:sld xmlns:a="http://schemas.openxmlformats.org/drawingml/2006/main" xmlns:p="http://schemas.openxmlformats.org/presentationml/2006/main" xmlns:r="http://schemas.openxmlformats.org/officeDocument/2006/relationships">
   <p:cSld>
     <p:spTree>
@@ -8000,6 +5870,324 @@
                 <a:latin typeface="Calibri"/>
               </a:rPr>
               <a:t>Headings cluster around ±180°. The naive mean says 7.6° (due east). The von Mises MLE atan2(Σ sin yᵢ, Σ cos yᵢ) gives −179.6°.</a:t>
+            </a:r>
+          </a:p>
+        </p:txBody>
+      </p:sp>
+    </p:spTree>
+  </p:cSld>
+  <p:clrMapOvr>
+    <a:masterClrMapping/>
+  </p:clrMapOvr>
+</p:sld>
+</file>
+
+<file path=ppt/slides/slide5.xml><?xml version="1.0" encoding="utf-8"?>
+<p:sld xmlns:a="http://schemas.openxmlformats.org/drawingml/2006/main" xmlns:p="http://schemas.openxmlformats.org/presentationml/2006/main" xmlns:r="http://schemas.openxmlformats.org/officeDocument/2006/relationships">
+  <p:cSld>
+    <p:spTree>
+      <p:nvGrpSpPr>
+        <p:cNvPr id="1" name=""/>
+        <p:cNvGrpSpPr/>
+        <p:nvPr/>
+      </p:nvGrpSpPr>
+      <p:grpSpPr/>
+      <p:sp>
+        <p:nvSpPr>
+          <p:cNvPr id="2" name="Title 1"/>
+          <p:cNvSpPr>
+            <a:spLocks noGrp="1"/>
+          </p:cNvSpPr>
+          <p:nvPr>
+            <p:ph type="title"/>
+          </p:nvPr>
+        </p:nvSpPr>
+        <p:spPr/>
+        <p:txBody>
+          <a:bodyPr/>
+          <a:lstStyle/>
+          <a:p>
+            <a:r>
+              <a:rPr b="1"/>
+              <a:t>Chapter 6: </a:t>
+            </a:r>
+            <a:r>
+              <a:rPr b="0"/>
+              <a:t>where you start matters</a:t>
+            </a:r>
+          </a:p>
+        </p:txBody>
+      </p:sp>
+      <p:sp>
+        <p:nvSpPr>
+          <p:cNvPr id="5" name="Slide Number Placeholder 4"/>
+          <p:cNvSpPr>
+            <a:spLocks noGrp="1"/>
+          </p:cNvSpPr>
+          <p:nvPr>
+            <p:ph type="sldNum" sz="quarter" idx="12"/>
+          </p:nvPr>
+        </p:nvSpPr>
+        <p:spPr/>
+        <p:txBody>
+          <a:bodyPr/>
+          <a:lstStyle/>
+          <a:p>
+            <a:fld id="{B6F15528-21DE-4FAA-801E-634DDDAF4B2B}" type="slidenum">
+              <a:rPr lang="en-US"/>
+              <a:t>‹#›</a:t>
+            </a:fld>
+          </a:p>
+        </p:txBody>
+      </p:sp>
+      <p:pic>
+        <p:nvPicPr>
+          <p:cNvPr id="6" name="Picture 5" descr="eq_4d09b72d646c.png"/>
+          <p:cNvPicPr>
+            <a:picLocks noChangeAspect="1"/>
+          </p:cNvPicPr>
+          <p:nvPr/>
+        </p:nvPicPr>
+        <p:blipFill>
+          <a:blip r:embed="rId3"/>
+          <a:stretch>
+            <a:fillRect/>
+          </a:stretch>
+        </p:blipFill>
+        <p:spPr>
+          <a:xfrm>
+            <a:off x="2891028" y="1280160"/>
+            <a:ext cx="6379464" cy="542544"/>
+          </a:xfrm>
+          <a:prstGeom prst="rect">
+            <a:avLst/>
+          </a:prstGeom>
+        </p:spPr>
+      </p:pic>
+      <p:pic>
+        <p:nvPicPr>
+          <p:cNvPr id="7" name="Picture 6" descr="c038_0.png"/>
+          <p:cNvPicPr>
+            <a:picLocks noChangeAspect="1"/>
+          </p:cNvPicPr>
+          <p:nvPr/>
+        </p:nvPicPr>
+        <p:blipFill>
+          <a:blip r:embed="rId4"/>
+          <a:stretch>
+            <a:fillRect/>
+          </a:stretch>
+        </p:blipFill>
+        <p:spPr>
+          <a:xfrm>
+            <a:off x="548640" y="2379024"/>
+            <a:ext cx="7498079" cy="3151510"/>
+          </a:xfrm>
+          <a:prstGeom prst="rect">
+            <a:avLst/>
+          </a:prstGeom>
+        </p:spPr>
+      </p:pic>
+      <p:sp>
+        <p:nvSpPr>
+          <p:cNvPr id="8" name="Rounded Rectangle 7"/>
+          <p:cNvSpPr/>
+          <p:nvPr/>
+        </p:nvSpPr>
+        <p:spPr>
+          <a:xfrm>
+            <a:off x="8275320" y="2057400"/>
+            <a:ext cx="3337560" cy="3794760"/>
+          </a:xfrm>
+          <a:prstGeom prst="roundRect">
+            <a:avLst>
+              <a:gd name="adj" fmla="val 4000"/>
+            </a:avLst>
+          </a:prstGeom>
+          <a:solidFill>
+            <a:srgbClr val="FFFFFF"/>
+          </a:solidFill>
+          <a:ln w="15875">
+            <a:solidFill>
+              <a:srgbClr val="73B0E6"/>
+            </a:solidFill>
+          </a:ln>
+          <a:effectLst/>
+        </p:spPr>
+        <p:style>
+          <a:lnRef idx="1">
+            <a:schemeClr val="accent1"/>
+          </a:lnRef>
+          <a:fillRef idx="3">
+            <a:schemeClr val="accent1"/>
+          </a:fillRef>
+          <a:effectRef idx="2">
+            <a:schemeClr val="accent1"/>
+          </a:effectRef>
+          <a:fontRef idx="minor">
+            <a:schemeClr val="lt1"/>
+          </a:fontRef>
+        </p:style>
+        <p:txBody>
+          <a:bodyPr rtlCol="0" anchor="ctr"/>
+          <a:lstStyle/>
+          <a:p>
+            <a:pPr algn="ctr"/>
+          </a:p>
+        </p:txBody>
+      </p:sp>
+      <p:sp>
+        <p:nvSpPr>
+          <p:cNvPr id="9" name="Rounded Rectangle 8"/>
+          <p:cNvSpPr/>
+          <p:nvPr/>
+        </p:nvSpPr>
+        <p:spPr>
+          <a:xfrm>
+            <a:off x="8412480" y="2194560"/>
+            <a:ext cx="3063240" cy="310896"/>
+          </a:xfrm>
+          <a:prstGeom prst="roundRect">
+            <a:avLst>
+              <a:gd name="adj" fmla="val 25000"/>
+            </a:avLst>
+          </a:prstGeom>
+          <a:solidFill>
+            <a:srgbClr val="008759"/>
+          </a:solidFill>
+          <a:ln>
+            <a:noFill/>
+          </a:ln>
+          <a:effectLst/>
+        </p:spPr>
+        <p:style>
+          <a:lnRef idx="1">
+            <a:schemeClr val="accent1"/>
+          </a:lnRef>
+          <a:fillRef idx="3">
+            <a:schemeClr val="accent1"/>
+          </a:fillRef>
+          <a:effectRef idx="2">
+            <a:schemeClr val="accent1"/>
+          </a:effectRef>
+          <a:fontRef idx="minor">
+            <a:schemeClr val="lt1"/>
+          </a:fontRef>
+        </p:style>
+        <p:txBody>
+          <a:bodyPr rtlCol="0" anchor="ctr" tIns="9144" bIns="9144"/>
+          <a:lstStyle/>
+          <a:p>
+            <a:pPr algn="ctr"/>
+            <a:r>
+              <a:rPr sz="1200" b="1">
+                <a:solidFill>
+                  <a:srgbClr val="FFFFFF"/>
+                </a:solidFill>
+                <a:latin typeface="Calibri"/>
+              </a:rPr>
+              <a:t>SGD (EQ 6.10)</a:t>
+            </a:r>
+          </a:p>
+        </p:txBody>
+      </p:sp>
+      <p:pic>
+        <p:nvPicPr>
+          <p:cNvPr id="10" name="Picture 9" descr="eq_b1acf9daec5b.png"/>
+          <p:cNvPicPr>
+            <a:picLocks noChangeAspect="1"/>
+          </p:cNvPicPr>
+          <p:nvPr/>
+        </p:nvPicPr>
+        <p:blipFill>
+          <a:blip r:embed="rId5"/>
+          <a:stretch>
+            <a:fillRect/>
+          </a:stretch>
+        </p:blipFill>
+        <p:spPr>
+          <a:xfrm>
+            <a:off x="8458200" y="2651760"/>
+            <a:ext cx="2240280" cy="612648"/>
+          </a:xfrm>
+          <a:prstGeom prst="rect">
+            <a:avLst/>
+          </a:prstGeom>
+        </p:spPr>
+      </p:pic>
+      <p:sp>
+        <p:nvSpPr>
+          <p:cNvPr id="11" name="TextBox 10"/>
+          <p:cNvSpPr txBox="1"/>
+          <p:nvPr/>
+        </p:nvSpPr>
+        <p:spPr>
+          <a:xfrm>
+            <a:off x="8412480" y="3429000"/>
+            <a:ext cx="3108960" cy="2377440"/>
+          </a:xfrm>
+          <a:prstGeom prst="rect">
+            <a:avLst/>
+          </a:prstGeom>
+          <a:noFill/>
+        </p:spPr>
+        <p:txBody>
+          <a:bodyPr wrap="square" lIns="45720" rIns="45720" tIns="27432" bIns="27432" anchor="t">
+            <a:spAutoFit/>
+          </a:bodyPr>
+          <a:lstStyle/>
+          <a:p>
+            <a:pPr algn="l" marL="201168" indent="-182880">
+              <a:spcAft>
+                <a:spcPts val="600"/>
+              </a:spcAft>
+              <a:buFont typeface="Arial"/>
+              <a:buChar char="•"/>
+            </a:pPr>
+            <a:r>
+              <a:rPr sz="1400" b="0" i="0">
+                <a:solidFill>
+                  <a:srgbClr val="404040"/>
+                </a:solidFill>
+                <a:latin typeface="Calibri"/>
+              </a:rPr>
+              <a:t>Random minibatches add noise that can hop valleys, but there's no guarantee</a:t>
+            </a:r>
+          </a:p>
+          <a:p>
+            <a:pPr algn="l" marL="201168" indent="-182880">
+              <a:spcAft>
+                <a:spcPts val="600"/>
+              </a:spcAft>
+              <a:buFont typeface="Arial"/>
+              <a:buChar char="•"/>
+            </a:pPr>
+            <a:r>
+              <a:rPr sz="1400" b="0" i="0">
+                <a:solidFill>
+                  <a:srgbClr val="404040"/>
+                </a:solidFill>
+                <a:latin typeface="Calibri"/>
+              </a:rPr>
+              <a:t>1 epoch = one pass over the data</a:t>
+            </a:r>
+          </a:p>
+          <a:p>
+            <a:pPr algn="l" marL="201168" indent="-182880">
+              <a:spcAft>
+                <a:spcPts val="600"/>
+              </a:spcAft>
+              <a:buFont typeface="Arial"/>
+              <a:buChar char="•"/>
+            </a:pPr>
+            <a:r>
+              <a:rPr sz="1400" b="0" i="0">
+                <a:solidFill>
+                  <a:srgbClr val="404040"/>
+                </a:solidFill>
+                <a:latin typeface="Calibri"/>
+              </a:rPr>
+              <a:t>Puzzle 6.2: a 10⁶-parameter Hessian has 10¹² entries (4 TB)</a:t>
             </a:r>
           </a:p>
         </p:txBody>
@@ -8039,11 +6227,11 @@
           <a:p>
             <a:r>
               <a:rPr b="1"/>
-              <a:t>Chapter 5: </a:t>
+              <a:t>Chapter 6: </a:t>
             </a:r>
             <a:r>
               <a:rPr b="0"/>
-              <a:t>predicting uncertainty</a:t>
+              <a:t>momentum and Adam</a:t>
             </a:r>
           </a:p>
         </p:txBody>
@@ -8070,9 +6258,64 @@
           </a:p>
         </p:txBody>
       </p:sp>
+      <p:sp>
+        <p:nvSpPr>
+          <p:cNvPr id="6" name="Rounded Rectangle 5"/>
+          <p:cNvSpPr/>
+          <p:nvPr/>
+        </p:nvSpPr>
+        <p:spPr>
+          <a:xfrm>
+            <a:off x="548640" y="1371600"/>
+            <a:ext cx="2377440" cy="310896"/>
+          </a:xfrm>
+          <a:prstGeom prst="roundRect">
+            <a:avLst>
+              <a:gd name="adj" fmla="val 25000"/>
+            </a:avLst>
+          </a:prstGeom>
+          <a:solidFill>
+            <a:srgbClr val="1366AB"/>
+          </a:solidFill>
+          <a:ln>
+            <a:noFill/>
+          </a:ln>
+          <a:effectLst/>
+        </p:spPr>
+        <p:style>
+          <a:lnRef idx="1">
+            <a:schemeClr val="accent1"/>
+          </a:lnRef>
+          <a:fillRef idx="3">
+            <a:schemeClr val="accent1"/>
+          </a:fillRef>
+          <a:effectRef idx="2">
+            <a:schemeClr val="accent1"/>
+          </a:effectRef>
+          <a:fontRef idx="minor">
+            <a:schemeClr val="lt1"/>
+          </a:fontRef>
+        </p:style>
+        <p:txBody>
+          <a:bodyPr rtlCol="0" anchor="ctr" tIns="9144" bIns="9144"/>
+          <a:lstStyle/>
+          <a:p>
+            <a:pPr algn="ctr"/>
+            <a:r>
+              <a:rPr sz="1200" b="1">
+                <a:solidFill>
+                  <a:srgbClr val="FFFFFF"/>
+                </a:solidFill>
+                <a:latin typeface="Calibri"/>
+              </a:rPr>
+              <a:t>MOMENTUM (6.11)</a:t>
+            </a:r>
+          </a:p>
+        </p:txBody>
+      </p:sp>
       <p:pic>
         <p:nvPicPr>
-          <p:cNvPr id="6" name="Picture 5" descr="c012_0.png"/>
+          <p:cNvPr id="7" name="Picture 6" descr="eq_67e540b79a03.png"/>
           <p:cNvPicPr>
             <a:picLocks noChangeAspect="1"/>
           </p:cNvPicPr>
@@ -8086,8 +6329,8 @@
         </p:blipFill>
         <p:spPr>
           <a:xfrm>
-            <a:off x="661271" y="1325880"/>
-            <a:ext cx="5809777" cy="4206240"/>
+            <a:off x="640080" y="1783080"/>
+            <a:ext cx="5212080" cy="310915"/>
           </a:xfrm>
           <a:prstGeom prst="rect">
             <a:avLst/>
@@ -8096,62 +6339,14 @@
       </p:pic>
       <p:sp>
         <p:nvSpPr>
-          <p:cNvPr id="7" name="Rounded Rectangle 6"/>
-          <p:cNvSpPr/>
-          <p:nvPr/>
-        </p:nvSpPr>
-        <p:spPr>
-          <a:xfrm>
-            <a:off x="6858000" y="1417320"/>
-            <a:ext cx="4754880" cy="4023360"/>
-          </a:xfrm>
-          <a:prstGeom prst="roundRect">
-            <a:avLst>
-              <a:gd name="adj" fmla="val 4000"/>
-            </a:avLst>
-          </a:prstGeom>
-          <a:solidFill>
-            <a:srgbClr val="FFFFFF"/>
-          </a:solidFill>
-          <a:ln w="15875">
-            <a:solidFill>
-              <a:srgbClr val="73B0E6"/>
-            </a:solidFill>
-          </a:ln>
-          <a:effectLst/>
-        </p:spPr>
-        <p:style>
-          <a:lnRef idx="1">
-            <a:schemeClr val="accent1"/>
-          </a:lnRef>
-          <a:fillRef idx="3">
-            <a:schemeClr val="accent1"/>
-          </a:fillRef>
-          <a:effectRef idx="2">
-            <a:schemeClr val="accent1"/>
-          </a:effectRef>
-          <a:fontRef idx="minor">
-            <a:schemeClr val="lt1"/>
-          </a:fontRef>
-        </p:style>
-        <p:txBody>
-          <a:bodyPr rtlCol="0" anchor="ctr"/>
-          <a:lstStyle/>
-          <a:p>
-            <a:pPr algn="ctr"/>
-          </a:p>
-        </p:txBody>
-      </p:sp>
-      <p:sp>
-        <p:nvSpPr>
           <p:cNvPr id="8" name="Rounded Rectangle 7"/>
           <p:cNvSpPr/>
           <p:nvPr/>
         </p:nvSpPr>
         <p:spPr>
           <a:xfrm>
-            <a:off x="6995160" y="1554480"/>
-            <a:ext cx="4480560" cy="310896"/>
+            <a:off x="548640" y="2322595"/>
+            <a:ext cx="2377440" cy="310896"/>
           </a:xfrm>
           <a:prstGeom prst="roundRect">
             <a:avLst>
@@ -8159,7 +6354,7 @@
             </a:avLst>
           </a:prstGeom>
           <a:solidFill>
-            <a:srgbClr val="008759"/>
+            <a:srgbClr val="1366AB"/>
           </a:solidFill>
           <a:ln>
             <a:noFill/>
@@ -8192,14 +6387,14 @@
                 </a:solidFill>
                 <a:latin typeface="Calibri"/>
               </a:rPr>
-              <a:t>HETEROSCEDASTIC REGRESSION (§5.3.4)</a:t>
+              <a:t>ADAM (6.15–6.17)</a:t>
             </a:r>
           </a:p>
         </p:txBody>
       </p:sp>
       <p:pic>
         <p:nvPicPr>
-          <p:cNvPr id="9" name="Picture 8" descr="eq_e782400ff186.png"/>
+          <p:cNvPr id="9" name="Picture 8" descr="eq_83f140f61d9c.png"/>
           <p:cNvPicPr>
             <a:picLocks noChangeAspect="1"/>
           </p:cNvPicPr>
@@ -8213,8 +6408,8 @@
         </p:blipFill>
         <p:spPr>
           <a:xfrm>
-            <a:off x="7040880" y="2057400"/>
-            <a:ext cx="4209288" cy="347472"/>
+            <a:off x="640080" y="2734075"/>
+            <a:ext cx="2776728" cy="384048"/>
           </a:xfrm>
           <a:prstGeom prst="rect">
             <a:avLst/>
@@ -8223,7 +6418,7 @@
       </p:pic>
       <p:pic>
         <p:nvPicPr>
-          <p:cNvPr id="10" name="Picture 9" descr="eq_033e1a816d9d.png"/>
+          <p:cNvPr id="10" name="Picture 9" descr="eq_a62ee5ad3aa3.png"/>
           <p:cNvPicPr>
             <a:picLocks noChangeAspect="1"/>
           </p:cNvPicPr>
@@ -8237,24 +6432,96 @@
         </p:blipFill>
         <p:spPr>
           <a:xfrm>
-            <a:off x="7040880" y="2697480"/>
-            <a:ext cx="2996184" cy="624840"/>
+            <a:off x="640080" y="3255283"/>
+            <a:ext cx="2852928" cy="490727"/>
           </a:xfrm>
           <a:prstGeom prst="rect">
             <a:avLst/>
           </a:prstGeom>
         </p:spPr>
       </p:pic>
-      <p:sp>
-        <p:nvSpPr>
-          <p:cNvPr id="11" name="TextBox 10"/>
+      <p:pic>
+        <p:nvPicPr>
+          <p:cNvPr id="11" name="Picture 10" descr="eq_a0e52410e2f6.png"/>
+          <p:cNvPicPr>
+            <a:picLocks noChangeAspect="1"/>
+          </p:cNvPicPr>
+          <p:nvPr/>
+        </p:nvPicPr>
+        <p:blipFill>
+          <a:blip r:embed="rId6"/>
+          <a:stretch>
+            <a:fillRect/>
+          </a:stretch>
+        </p:blipFill>
+        <p:spPr>
+          <a:xfrm>
+            <a:off x="640080" y="3883171"/>
+            <a:ext cx="2276856" cy="530352"/>
+          </a:xfrm>
+          <a:prstGeom prst="rect">
+            <a:avLst/>
+          </a:prstGeom>
+        </p:spPr>
+      </p:pic>
+      <p:sp>
+        <p:nvSpPr>
+          <p:cNvPr id="12" name="Rounded Rectangle 11"/>
+          <p:cNvSpPr/>
+          <p:nvPr/>
+        </p:nvSpPr>
+        <p:spPr>
+          <a:xfrm>
+            <a:off x="548640" y="4642123"/>
+            <a:ext cx="5212080" cy="1255756"/>
+          </a:xfrm>
+          <a:prstGeom prst="roundRect">
+            <a:avLst>
+              <a:gd name="adj" fmla="val 4000"/>
+            </a:avLst>
+          </a:prstGeom>
+          <a:solidFill>
+            <a:srgbClr val="FFFFFF"/>
+          </a:solidFill>
+          <a:ln w="15875">
+            <a:solidFill>
+              <a:srgbClr val="EF8E00"/>
+            </a:solidFill>
+          </a:ln>
+          <a:effectLst/>
+        </p:spPr>
+        <p:style>
+          <a:lnRef idx="1">
+            <a:schemeClr val="accent1"/>
+          </a:lnRef>
+          <a:fillRef idx="3">
+            <a:schemeClr val="accent1"/>
+          </a:fillRef>
+          <a:effectRef idx="2">
+            <a:schemeClr val="accent1"/>
+          </a:effectRef>
+          <a:fontRef idx="minor">
+            <a:schemeClr val="lt1"/>
+          </a:fontRef>
+        </p:style>
+        <p:txBody>
+          <a:bodyPr rtlCol="0" anchor="ctr"/>
+          <a:lstStyle/>
+          <a:p>
+            <a:pPr algn="ctr"/>
+          </a:p>
+        </p:txBody>
+      </p:sp>
+      <p:sp>
+        <p:nvSpPr>
+          <p:cNvPr id="13" name="TextBox 12"/>
           <p:cNvSpPr txBox="1"/>
           <p:nvPr/>
         </p:nvSpPr>
         <p:spPr>
           <a:xfrm>
-            <a:off x="7040880" y="3474720"/>
-            <a:ext cx="4389120" cy="1920240"/>
+            <a:off x="685800" y="4715275"/>
+            <a:ext cx="4937760" cy="1118596"/>
           </a:xfrm>
           <a:prstGeom prst="rect">
             <a:avLst/>
@@ -8267,79 +6534,63 @@
           </a:bodyPr>
           <a:lstStyle/>
           <a:p>
-            <a:pPr algn="l" marL="201168" indent="-182880">
+            <a:pPr algn="l">
               <a:spcAft>
                 <a:spcPts val="600"/>
               </a:spcAft>
-              <a:buFont typeface="Arial"/>
-              <a:buChar char="•"/>
             </a:pPr>
             <a:r>
-              <a:rPr sz="1500" b="0" i="0">
+              <a:rPr sz="1500" b="1" i="0">
+                <a:solidFill>
+                  <a:srgbClr val="EF8E00"/>
+                </a:solidFill>
+                <a:latin typeface="Calibri"/>
+              </a:rPr>
+              <a:t>Challenge 6: race to the burrow</a:t>
+            </a:r>
+          </a:p>
+          <a:p>
+            <a:pPr algn="l">
+              <a:spcAft>
+                <a:spcPts val="600"/>
+              </a:spcAft>
+            </a:pPr>
+            <a:r>
+              <a:rPr sz="1400" b="0" i="0">
                 <a:solidFill>
                   <a:srgbClr val="404040"/>
                 </a:solidFill>
                 <a:latin typeface="Calibri"/>
               </a:rPr>
-              <a:t>Two outputs: a mean and a variance</a:t>
-            </a:r>
-          </a:p>
-          <a:p>
-            <a:pPr algn="l" marL="201168" indent="-182880">
-              <a:spcAft>
-                <a:spcPts val="600"/>
-              </a:spcAft>
-              <a:buFont typeface="Arial"/>
-              <a:buChar char="•"/>
-            </a:pPr>
-            <a:r>
-              <a:rPr sz="1500" b="0" i="0">
-                <a:solidFill>
-                  <a:srgbClr val="404040"/>
-                </a:solidFill>
-                <a:latin typeface="Calibri"/>
-              </a:rPr>
-              <a:t>Softplus keeps the variance positive</a:t>
-            </a:r>
-          </a:p>
-          <a:p>
-            <a:pPr algn="l" marL="201168" indent="-182880">
-              <a:spcAft>
-                <a:spcPts val="600"/>
-              </a:spcAft>
-              <a:buFont typeface="Arial"/>
-              <a:buChar char="•"/>
-            </a:pPr>
-            <a:r>
-              <a:rPr sz="1500" b="0" i="0">
-                <a:solidFill>
-                  <a:srgbClr val="404040"/>
-                </a:solidFill>
-                <a:latin typeface="Calibri"/>
-              </a:rPr>
-              <a:t>Pups get more variable as they grow, and the band widens with age</a:t>
-            </a:r>
-          </a:p>
-          <a:p>
-            <a:pPr algn="l" marL="201168" indent="-182880">
-              <a:spcAft>
-                <a:spcPts val="600"/>
-              </a:spcAft>
-              <a:buFont typeface="Arial"/>
-              <a:buChar char="•"/>
-            </a:pPr>
-            <a:r>
-              <a:rPr sz="1500" b="1" i="0">
-                <a:solidFill>
-                  <a:srgbClr val="008759"/>
-                </a:solidFill>
-                <a:latin typeface="Calibri"/>
-              </a:rPr>
-              <a:t>Assay data often look like this too</a:t>
-            </a:r>
-          </a:p>
-        </p:txBody>
-      </p:sp>
+              <a:t>L(a, b) = (1 − a)² + 20(b − a²)². Fewest steps wins: bronze &lt; 2,000, silver &lt; 600, gold &lt; 200.</a:t>
+            </a:r>
+          </a:p>
+        </p:txBody>
+      </p:sp>
+      <p:pic>
+        <p:nvPicPr>
+          <p:cNvPr id="14" name="Picture 13" descr="c051_0.png"/>
+          <p:cNvPicPr>
+            <a:picLocks noChangeAspect="1"/>
+          </p:cNvPicPr>
+          <p:nvPr/>
+        </p:nvPicPr>
+        <p:blipFill>
+          <a:blip r:embed="rId7"/>
+          <a:stretch>
+            <a:fillRect/>
+          </a:stretch>
+        </p:blipFill>
+        <p:spPr>
+          <a:xfrm>
+            <a:off x="5943600" y="2550023"/>
+            <a:ext cx="5669280" cy="2123713"/>
+          </a:xfrm>
+          <a:prstGeom prst="rect">
+            <a:avLst/>
+          </a:prstGeom>
+        </p:spPr>
+      </p:pic>
     </p:spTree>
   </p:cSld>
   <p:clrMapOvr>
@@ -8375,728 +6626,11 @@
           <a:p>
             <a:r>
               <a:rPr b="1"/>
-              <a:t>Chapter 6: </a:t>
+              <a:t>Hands-on: </a:t>
             </a:r>
             <a:r>
               <a:rPr b="0"/>
-              <a:t>where you start matters</a:t>
-            </a:r>
-          </a:p>
-        </p:txBody>
-      </p:sp>
-      <p:sp>
-        <p:nvSpPr>
-          <p:cNvPr id="5" name="Slide Number Placeholder 4"/>
-          <p:cNvSpPr>
-            <a:spLocks noGrp="1"/>
-          </p:cNvSpPr>
-          <p:nvPr>
-            <p:ph type="sldNum" sz="quarter" idx="12"/>
-          </p:nvPr>
-        </p:nvSpPr>
-        <p:spPr/>
-        <p:txBody>
-          <a:bodyPr/>
-          <a:lstStyle/>
-          <a:p>
-            <a:fld id="{B6F15528-21DE-4FAA-801E-634DDDAF4B2B}" type="slidenum">
-              <a:rPr lang="en-US"/>
-              <a:t>‹#›</a:t>
-            </a:fld>
-          </a:p>
-        </p:txBody>
-      </p:sp>
-      <p:pic>
-        <p:nvPicPr>
-          <p:cNvPr id="6" name="Picture 5" descr="eq_4d09b72d646c.png"/>
-          <p:cNvPicPr>
-            <a:picLocks noChangeAspect="1"/>
-          </p:cNvPicPr>
-          <p:nvPr/>
-        </p:nvPicPr>
-        <p:blipFill>
-          <a:blip r:embed="rId3"/>
-          <a:stretch>
-            <a:fillRect/>
-          </a:stretch>
-        </p:blipFill>
-        <p:spPr>
-          <a:xfrm>
-            <a:off x="2891028" y="1280160"/>
-            <a:ext cx="6379464" cy="542544"/>
-          </a:xfrm>
-          <a:prstGeom prst="rect">
-            <a:avLst/>
-          </a:prstGeom>
-        </p:spPr>
-      </p:pic>
-      <p:pic>
-        <p:nvPicPr>
-          <p:cNvPr id="7" name="Picture 6" descr="c038_0.png"/>
-          <p:cNvPicPr>
-            <a:picLocks noChangeAspect="1"/>
-          </p:cNvPicPr>
-          <p:nvPr/>
-        </p:nvPicPr>
-        <p:blipFill>
-          <a:blip r:embed="rId4"/>
-          <a:stretch>
-            <a:fillRect/>
-          </a:stretch>
-        </p:blipFill>
-        <p:spPr>
-          <a:xfrm>
-            <a:off x="548640" y="2379024"/>
-            <a:ext cx="7498079" cy="3151510"/>
-          </a:xfrm>
-          <a:prstGeom prst="rect">
-            <a:avLst/>
-          </a:prstGeom>
-        </p:spPr>
-      </p:pic>
-      <p:sp>
-        <p:nvSpPr>
-          <p:cNvPr id="8" name="Rounded Rectangle 7"/>
-          <p:cNvSpPr/>
-          <p:nvPr/>
-        </p:nvSpPr>
-        <p:spPr>
-          <a:xfrm>
-            <a:off x="8275320" y="2057400"/>
-            <a:ext cx="3337560" cy="3794760"/>
-          </a:xfrm>
-          <a:prstGeom prst="roundRect">
-            <a:avLst>
-              <a:gd name="adj" fmla="val 4000"/>
-            </a:avLst>
-          </a:prstGeom>
-          <a:solidFill>
-            <a:srgbClr val="FFFFFF"/>
-          </a:solidFill>
-          <a:ln w="15875">
-            <a:solidFill>
-              <a:srgbClr val="73B0E6"/>
-            </a:solidFill>
-          </a:ln>
-          <a:effectLst/>
-        </p:spPr>
-        <p:style>
-          <a:lnRef idx="1">
-            <a:schemeClr val="accent1"/>
-          </a:lnRef>
-          <a:fillRef idx="3">
-            <a:schemeClr val="accent1"/>
-          </a:fillRef>
-          <a:effectRef idx="2">
-            <a:schemeClr val="accent1"/>
-          </a:effectRef>
-          <a:fontRef idx="minor">
-            <a:schemeClr val="lt1"/>
-          </a:fontRef>
-        </p:style>
-        <p:txBody>
-          <a:bodyPr rtlCol="0" anchor="ctr"/>
-          <a:lstStyle/>
-          <a:p>
-            <a:pPr algn="ctr"/>
-          </a:p>
-        </p:txBody>
-      </p:sp>
-      <p:sp>
-        <p:nvSpPr>
-          <p:cNvPr id="9" name="Rounded Rectangle 8"/>
-          <p:cNvSpPr/>
-          <p:nvPr/>
-        </p:nvSpPr>
-        <p:spPr>
-          <a:xfrm>
-            <a:off x="8412480" y="2194560"/>
-            <a:ext cx="3063240" cy="310896"/>
-          </a:xfrm>
-          <a:prstGeom prst="roundRect">
-            <a:avLst>
-              <a:gd name="adj" fmla="val 25000"/>
-            </a:avLst>
-          </a:prstGeom>
-          <a:solidFill>
-            <a:srgbClr val="008759"/>
-          </a:solidFill>
-          <a:ln>
-            <a:noFill/>
-          </a:ln>
-          <a:effectLst/>
-        </p:spPr>
-        <p:style>
-          <a:lnRef idx="1">
-            <a:schemeClr val="accent1"/>
-          </a:lnRef>
-          <a:fillRef idx="3">
-            <a:schemeClr val="accent1"/>
-          </a:fillRef>
-          <a:effectRef idx="2">
-            <a:schemeClr val="accent1"/>
-          </a:effectRef>
-          <a:fontRef idx="minor">
-            <a:schemeClr val="lt1"/>
-          </a:fontRef>
-        </p:style>
-        <p:txBody>
-          <a:bodyPr rtlCol="0" anchor="ctr" tIns="9144" bIns="9144"/>
-          <a:lstStyle/>
-          <a:p>
-            <a:pPr algn="ctr"/>
-            <a:r>
-              <a:rPr sz="1200" b="1">
-                <a:solidFill>
-                  <a:srgbClr val="FFFFFF"/>
-                </a:solidFill>
-                <a:latin typeface="Calibri"/>
-              </a:rPr>
-              <a:t>SGD (EQ 6.10)</a:t>
-            </a:r>
-          </a:p>
-        </p:txBody>
-      </p:sp>
-      <p:pic>
-        <p:nvPicPr>
-          <p:cNvPr id="10" name="Picture 9" descr="eq_b1acf9daec5b.png"/>
-          <p:cNvPicPr>
-            <a:picLocks noChangeAspect="1"/>
-          </p:cNvPicPr>
-          <p:nvPr/>
-        </p:nvPicPr>
-        <p:blipFill>
-          <a:blip r:embed="rId5"/>
-          <a:stretch>
-            <a:fillRect/>
-          </a:stretch>
-        </p:blipFill>
-        <p:spPr>
-          <a:xfrm>
-            <a:off x="8458200" y="2651760"/>
-            <a:ext cx="2240280" cy="612648"/>
-          </a:xfrm>
-          <a:prstGeom prst="rect">
-            <a:avLst/>
-          </a:prstGeom>
-        </p:spPr>
-      </p:pic>
-      <p:sp>
-        <p:nvSpPr>
-          <p:cNvPr id="11" name="TextBox 10"/>
-          <p:cNvSpPr txBox="1"/>
-          <p:nvPr/>
-        </p:nvSpPr>
-        <p:spPr>
-          <a:xfrm>
-            <a:off x="8412480" y="3429000"/>
-            <a:ext cx="3108960" cy="2377440"/>
-          </a:xfrm>
-          <a:prstGeom prst="rect">
-            <a:avLst/>
-          </a:prstGeom>
-          <a:noFill/>
-        </p:spPr>
-        <p:txBody>
-          <a:bodyPr wrap="square" lIns="45720" rIns="45720" tIns="27432" bIns="27432" anchor="t">
-            <a:spAutoFit/>
-          </a:bodyPr>
-          <a:lstStyle/>
-          <a:p>
-            <a:pPr algn="l" marL="201168" indent="-182880">
-              <a:spcAft>
-                <a:spcPts val="600"/>
-              </a:spcAft>
-              <a:buFont typeface="Arial"/>
-              <a:buChar char="•"/>
-            </a:pPr>
-            <a:r>
-              <a:rPr sz="1400" b="0" i="0">
-                <a:solidFill>
-                  <a:srgbClr val="404040"/>
-                </a:solidFill>
-                <a:latin typeface="Calibri"/>
-              </a:rPr>
-              <a:t>Random minibatches add noise that can hop valleys, but there's no guarantee</a:t>
-            </a:r>
-          </a:p>
-          <a:p>
-            <a:pPr algn="l" marL="201168" indent="-182880">
-              <a:spcAft>
-                <a:spcPts val="600"/>
-              </a:spcAft>
-              <a:buFont typeface="Arial"/>
-              <a:buChar char="•"/>
-            </a:pPr>
-            <a:r>
-              <a:rPr sz="1400" b="0" i="0">
-                <a:solidFill>
-                  <a:srgbClr val="404040"/>
-                </a:solidFill>
-                <a:latin typeface="Calibri"/>
-              </a:rPr>
-              <a:t>1 epoch = one pass over the data</a:t>
-            </a:r>
-          </a:p>
-          <a:p>
-            <a:pPr algn="l" marL="201168" indent="-182880">
-              <a:spcAft>
-                <a:spcPts val="600"/>
-              </a:spcAft>
-              <a:buFont typeface="Arial"/>
-              <a:buChar char="•"/>
-            </a:pPr>
-            <a:r>
-              <a:rPr sz="1400" b="0" i="0">
-                <a:solidFill>
-                  <a:srgbClr val="404040"/>
-                </a:solidFill>
-                <a:latin typeface="Calibri"/>
-              </a:rPr>
-              <a:t>Puzzle 6.2: a 10⁶-parameter Hessian has 10¹² entries (4 TB)</a:t>
-            </a:r>
-          </a:p>
-        </p:txBody>
-      </p:sp>
-    </p:spTree>
-  </p:cSld>
-  <p:clrMapOvr>
-    <a:masterClrMapping/>
-  </p:clrMapOvr>
-</p:sld>
-</file>
-
-<file path=ppt/slides/slide8.xml><?xml version="1.0" encoding="utf-8"?>
-<p:sld xmlns:a="http://schemas.openxmlformats.org/drawingml/2006/main" xmlns:p="http://schemas.openxmlformats.org/presentationml/2006/main" xmlns:r="http://schemas.openxmlformats.org/officeDocument/2006/relationships">
-  <p:cSld>
-    <p:spTree>
-      <p:nvGrpSpPr>
-        <p:cNvPr id="1" name=""/>
-        <p:cNvGrpSpPr/>
-        <p:nvPr/>
-      </p:nvGrpSpPr>
-      <p:grpSpPr/>
-      <p:sp>
-        <p:nvSpPr>
-          <p:cNvPr id="2" name="Title 1"/>
-          <p:cNvSpPr>
-            <a:spLocks noGrp="1"/>
-          </p:cNvSpPr>
-          <p:nvPr>
-            <p:ph type="title"/>
-          </p:nvPr>
-        </p:nvSpPr>
-        <p:spPr/>
-        <p:txBody>
-          <a:bodyPr/>
-          <a:lstStyle/>
-          <a:p>
-            <a:r>
-              <a:rPr b="1"/>
-              <a:t>Chapter 6: </a:t>
-            </a:r>
-            <a:r>
-              <a:rPr b="0"/>
-              <a:t>momentum and Adam</a:t>
-            </a:r>
-          </a:p>
-        </p:txBody>
-      </p:sp>
-      <p:sp>
-        <p:nvSpPr>
-          <p:cNvPr id="5" name="Slide Number Placeholder 4"/>
-          <p:cNvSpPr>
-            <a:spLocks noGrp="1"/>
-          </p:cNvSpPr>
-          <p:nvPr>
-            <p:ph type="sldNum" sz="quarter" idx="12"/>
-          </p:nvPr>
-        </p:nvSpPr>
-        <p:spPr/>
-        <p:txBody>
-          <a:bodyPr/>
-          <a:lstStyle/>
-          <a:p>
-            <a:fld id="{B6F15528-21DE-4FAA-801E-634DDDAF4B2B}" type="slidenum">
-              <a:rPr lang="en-US"/>
-              <a:t>‹#›</a:t>
-            </a:fld>
-          </a:p>
-        </p:txBody>
-      </p:sp>
-      <p:sp>
-        <p:nvSpPr>
-          <p:cNvPr id="6" name="Rounded Rectangle 5"/>
-          <p:cNvSpPr/>
-          <p:nvPr/>
-        </p:nvSpPr>
-        <p:spPr>
-          <a:xfrm>
-            <a:off x="548640" y="1371600"/>
-            <a:ext cx="2377440" cy="310896"/>
-          </a:xfrm>
-          <a:prstGeom prst="roundRect">
-            <a:avLst>
-              <a:gd name="adj" fmla="val 25000"/>
-            </a:avLst>
-          </a:prstGeom>
-          <a:solidFill>
-            <a:srgbClr val="1366AB"/>
-          </a:solidFill>
-          <a:ln>
-            <a:noFill/>
-          </a:ln>
-          <a:effectLst/>
-        </p:spPr>
-        <p:style>
-          <a:lnRef idx="1">
-            <a:schemeClr val="accent1"/>
-          </a:lnRef>
-          <a:fillRef idx="3">
-            <a:schemeClr val="accent1"/>
-          </a:fillRef>
-          <a:effectRef idx="2">
-            <a:schemeClr val="accent1"/>
-          </a:effectRef>
-          <a:fontRef idx="minor">
-            <a:schemeClr val="lt1"/>
-          </a:fontRef>
-        </p:style>
-        <p:txBody>
-          <a:bodyPr rtlCol="0" anchor="ctr" tIns="9144" bIns="9144"/>
-          <a:lstStyle/>
-          <a:p>
-            <a:pPr algn="ctr"/>
-            <a:r>
-              <a:rPr sz="1200" b="1">
-                <a:solidFill>
-                  <a:srgbClr val="FFFFFF"/>
-                </a:solidFill>
-                <a:latin typeface="Calibri"/>
-              </a:rPr>
-              <a:t>MOMENTUM (6.11)</a:t>
-            </a:r>
-          </a:p>
-        </p:txBody>
-      </p:sp>
-      <p:pic>
-        <p:nvPicPr>
-          <p:cNvPr id="7" name="Picture 6" descr="eq_67e540b79a03.png"/>
-          <p:cNvPicPr>
-            <a:picLocks noChangeAspect="1"/>
-          </p:cNvPicPr>
-          <p:nvPr/>
-        </p:nvPicPr>
-        <p:blipFill>
-          <a:blip r:embed="rId3"/>
-          <a:stretch>
-            <a:fillRect/>
-          </a:stretch>
-        </p:blipFill>
-        <p:spPr>
-          <a:xfrm>
-            <a:off x="640080" y="1783080"/>
-            <a:ext cx="5212080" cy="310915"/>
-          </a:xfrm>
-          <a:prstGeom prst="rect">
-            <a:avLst/>
-          </a:prstGeom>
-        </p:spPr>
-      </p:pic>
-      <p:sp>
-        <p:nvSpPr>
-          <p:cNvPr id="8" name="Rounded Rectangle 7"/>
-          <p:cNvSpPr/>
-          <p:nvPr/>
-        </p:nvSpPr>
-        <p:spPr>
-          <a:xfrm>
-            <a:off x="548640" y="2322595"/>
-            <a:ext cx="2377440" cy="310896"/>
-          </a:xfrm>
-          <a:prstGeom prst="roundRect">
-            <a:avLst>
-              <a:gd name="adj" fmla="val 25000"/>
-            </a:avLst>
-          </a:prstGeom>
-          <a:solidFill>
-            <a:srgbClr val="1366AB"/>
-          </a:solidFill>
-          <a:ln>
-            <a:noFill/>
-          </a:ln>
-          <a:effectLst/>
-        </p:spPr>
-        <p:style>
-          <a:lnRef idx="1">
-            <a:schemeClr val="accent1"/>
-          </a:lnRef>
-          <a:fillRef idx="3">
-            <a:schemeClr val="accent1"/>
-          </a:fillRef>
-          <a:effectRef idx="2">
-            <a:schemeClr val="accent1"/>
-          </a:effectRef>
-          <a:fontRef idx="minor">
-            <a:schemeClr val="lt1"/>
-          </a:fontRef>
-        </p:style>
-        <p:txBody>
-          <a:bodyPr rtlCol="0" anchor="ctr" tIns="9144" bIns="9144"/>
-          <a:lstStyle/>
-          <a:p>
-            <a:pPr algn="ctr"/>
-            <a:r>
-              <a:rPr sz="1200" b="1">
-                <a:solidFill>
-                  <a:srgbClr val="FFFFFF"/>
-                </a:solidFill>
-                <a:latin typeface="Calibri"/>
-              </a:rPr>
-              <a:t>ADAM (6.15–6.17)</a:t>
-            </a:r>
-          </a:p>
-        </p:txBody>
-      </p:sp>
-      <p:pic>
-        <p:nvPicPr>
-          <p:cNvPr id="9" name="Picture 8" descr="eq_83f140f61d9c.png"/>
-          <p:cNvPicPr>
-            <a:picLocks noChangeAspect="1"/>
-          </p:cNvPicPr>
-          <p:nvPr/>
-        </p:nvPicPr>
-        <p:blipFill>
-          <a:blip r:embed="rId4"/>
-          <a:stretch>
-            <a:fillRect/>
-          </a:stretch>
-        </p:blipFill>
-        <p:spPr>
-          <a:xfrm>
-            <a:off x="640080" y="2734075"/>
-            <a:ext cx="2776728" cy="384048"/>
-          </a:xfrm>
-          <a:prstGeom prst="rect">
-            <a:avLst/>
-          </a:prstGeom>
-        </p:spPr>
-      </p:pic>
-      <p:pic>
-        <p:nvPicPr>
-          <p:cNvPr id="10" name="Picture 9" descr="eq_a62ee5ad3aa3.png"/>
-          <p:cNvPicPr>
-            <a:picLocks noChangeAspect="1"/>
-          </p:cNvPicPr>
-          <p:nvPr/>
-        </p:nvPicPr>
-        <p:blipFill>
-          <a:blip r:embed="rId5"/>
-          <a:stretch>
-            <a:fillRect/>
-          </a:stretch>
-        </p:blipFill>
-        <p:spPr>
-          <a:xfrm>
-            <a:off x="640080" y="3255283"/>
-            <a:ext cx="2852928" cy="490727"/>
-          </a:xfrm>
-          <a:prstGeom prst="rect">
-            <a:avLst/>
-          </a:prstGeom>
-        </p:spPr>
-      </p:pic>
-      <p:pic>
-        <p:nvPicPr>
-          <p:cNvPr id="11" name="Picture 10" descr="eq_a0e52410e2f6.png"/>
-          <p:cNvPicPr>
-            <a:picLocks noChangeAspect="1"/>
-          </p:cNvPicPr>
-          <p:nvPr/>
-        </p:nvPicPr>
-        <p:blipFill>
-          <a:blip r:embed="rId6"/>
-          <a:stretch>
-            <a:fillRect/>
-          </a:stretch>
-        </p:blipFill>
-        <p:spPr>
-          <a:xfrm>
-            <a:off x="640080" y="3883171"/>
-            <a:ext cx="2276856" cy="530352"/>
-          </a:xfrm>
-          <a:prstGeom prst="rect">
-            <a:avLst/>
-          </a:prstGeom>
-        </p:spPr>
-      </p:pic>
-      <p:sp>
-        <p:nvSpPr>
-          <p:cNvPr id="12" name="Rounded Rectangle 11"/>
-          <p:cNvSpPr/>
-          <p:nvPr/>
-        </p:nvSpPr>
-        <p:spPr>
-          <a:xfrm>
-            <a:off x="548640" y="4642123"/>
-            <a:ext cx="5212080" cy="1255756"/>
-          </a:xfrm>
-          <a:prstGeom prst="roundRect">
-            <a:avLst>
-              <a:gd name="adj" fmla="val 4000"/>
-            </a:avLst>
-          </a:prstGeom>
-          <a:solidFill>
-            <a:srgbClr val="FFFFFF"/>
-          </a:solidFill>
-          <a:ln w="15875">
-            <a:solidFill>
-              <a:srgbClr val="EF8E00"/>
-            </a:solidFill>
-          </a:ln>
-          <a:effectLst/>
-        </p:spPr>
-        <p:style>
-          <a:lnRef idx="1">
-            <a:schemeClr val="accent1"/>
-          </a:lnRef>
-          <a:fillRef idx="3">
-            <a:schemeClr val="accent1"/>
-          </a:fillRef>
-          <a:effectRef idx="2">
-            <a:schemeClr val="accent1"/>
-          </a:effectRef>
-          <a:fontRef idx="minor">
-            <a:schemeClr val="lt1"/>
-          </a:fontRef>
-        </p:style>
-        <p:txBody>
-          <a:bodyPr rtlCol="0" anchor="ctr"/>
-          <a:lstStyle/>
-          <a:p>
-            <a:pPr algn="ctr"/>
-          </a:p>
-        </p:txBody>
-      </p:sp>
-      <p:sp>
-        <p:nvSpPr>
-          <p:cNvPr id="13" name="TextBox 12"/>
-          <p:cNvSpPr txBox="1"/>
-          <p:nvPr/>
-        </p:nvSpPr>
-        <p:spPr>
-          <a:xfrm>
-            <a:off x="685800" y="4715275"/>
-            <a:ext cx="4937760" cy="1118596"/>
-          </a:xfrm>
-          <a:prstGeom prst="rect">
-            <a:avLst/>
-          </a:prstGeom>
-          <a:noFill/>
-        </p:spPr>
-        <p:txBody>
-          <a:bodyPr wrap="square" lIns="45720" rIns="45720" tIns="27432" bIns="27432" anchor="t">
-            <a:spAutoFit/>
-          </a:bodyPr>
-          <a:lstStyle/>
-          <a:p>
-            <a:pPr algn="l">
-              <a:spcAft>
-                <a:spcPts val="600"/>
-              </a:spcAft>
-            </a:pPr>
-            <a:r>
-              <a:rPr sz="1500" b="1" i="0">
-                <a:solidFill>
-                  <a:srgbClr val="EF8E00"/>
-                </a:solidFill>
-                <a:latin typeface="Calibri"/>
-              </a:rPr>
-              <a:t>Challenge 6: race to the burrow</a:t>
-            </a:r>
-          </a:p>
-          <a:p>
-            <a:pPr algn="l">
-              <a:spcAft>
-                <a:spcPts val="600"/>
-              </a:spcAft>
-            </a:pPr>
-            <a:r>
-              <a:rPr sz="1400" b="0" i="0">
-                <a:solidFill>
-                  <a:srgbClr val="404040"/>
-                </a:solidFill>
-                <a:latin typeface="Calibri"/>
-              </a:rPr>
-              <a:t>L(a, b) = (1 − a)² + 20(b − a²)². Fewest steps wins: bronze &lt; 2,000, silver &lt; 600, gold &lt; 200.</a:t>
-            </a:r>
-          </a:p>
-        </p:txBody>
-      </p:sp>
-      <p:pic>
-        <p:nvPicPr>
-          <p:cNvPr id="14" name="Picture 13" descr="c051_0.png"/>
-          <p:cNvPicPr>
-            <a:picLocks noChangeAspect="1"/>
-          </p:cNvPicPr>
-          <p:nvPr/>
-        </p:nvPicPr>
-        <p:blipFill>
-          <a:blip r:embed="rId7"/>
-          <a:stretch>
-            <a:fillRect/>
-          </a:stretch>
-        </p:blipFill>
-        <p:spPr>
-          <a:xfrm>
-            <a:off x="5943600" y="2550023"/>
-            <a:ext cx="5669280" cy="2123713"/>
-          </a:xfrm>
-          <a:prstGeom prst="rect">
-            <a:avLst/>
-          </a:prstGeom>
-        </p:spPr>
-      </p:pic>
-    </p:spTree>
-  </p:cSld>
-  <p:clrMapOvr>
-    <a:masterClrMapping/>
-  </p:clrMapOvr>
-</p:sld>
-</file>
-
-<file path=ppt/slides/slide9.xml><?xml version="1.0" encoding="utf-8"?>
-<p:sld xmlns:a="http://schemas.openxmlformats.org/drawingml/2006/main" xmlns:p="http://schemas.openxmlformats.org/presentationml/2006/main" xmlns:r="http://schemas.openxmlformats.org/officeDocument/2006/relationships">
-  <p:cSld>
-    <p:spTree>
-      <p:nvGrpSpPr>
-        <p:cNvPr id="1" name=""/>
-        <p:cNvGrpSpPr/>
-        <p:nvPr/>
-      </p:nvGrpSpPr>
-      <p:grpSpPr/>
-      <p:sp>
-        <p:nvSpPr>
-          <p:cNvPr id="2" name="Title 1"/>
-          <p:cNvSpPr>
-            <a:spLocks noGrp="1"/>
-          </p:cNvSpPr>
-          <p:nvPr>
-            <p:ph type="title"/>
-          </p:nvPr>
-        </p:nvSpPr>
-        <p:spPr/>
-        <p:txBody>
-          <a:bodyPr/>
-          <a:lstStyle/>
-          <a:p>
-            <a:r>
-              <a:rPr b="1"/>
-              <a:t>Hands-on: </a:t>
-            </a:r>
-            <a:r>
-              <a:rPr b="0"/>
-              <a:t>10 puzzles, 21 points</a:t>
+              <a:t>10 puzzles, 1 challenge</a:t>
             </a:r>
           </a:p>
         </p:txBody>
@@ -9143,8 +6677,7 @@
               </a:tblPr>
               <a:tblGrid>
                 <a:gridCol w="1737360"/>
-                <a:gridCol w="7223760"/>
-                <a:gridCol w="914400"/>
+                <a:gridCol w="8138160"/>
                 <a:gridCol w="1188720"/>
               </a:tblGrid>
               <a:tr h="566928">
@@ -9183,28 +6716,6 @@
                           <a:latin typeface="Calibri"/>
                         </a:rPr>
                         <a:t>Puzzles</a:t>
-                      </a:r>
-                    </a:p>
-                  </a:txBody>
-                  <a:tcPr marL="54864" marR="54864" marT="27432" marB="27432" anchor="ctr">
-                    <a:solidFill>
-                      <a:srgbClr val="008759"/>
-                    </a:solidFill>
-                  </a:tcPr>
-                </a:tc>
-                <a:tc>
-                  <a:txBody>
-                    <a:bodyPr/>
-                    <a:lstStyle/>
-                    <a:p>
-                      <a:r>
-                        <a:rPr sz="1400" b="1">
-                          <a:solidFill>
-                            <a:srgbClr val="FFFFFF"/>
-                          </a:solidFill>
-                          <a:latin typeface="Calibri"/>
-                        </a:rPr>
-                        <a:t>Points</a:t>
                       </a:r>
                     </a:p>
                   </a:txBody>
@@ -9294,28 +6805,6 @@
                           </a:solidFill>
                           <a:latin typeface="Calibri"/>
                         </a:rPr>
-                        <a:t>12</a:t>
-                      </a:r>
-                    </a:p>
-                  </a:txBody>
-                  <a:tcPr marL="54864" marR="54864" marT="27432" marB="27432" anchor="ctr">
-                    <a:solidFill>
-                      <a:srgbClr val="FFFFFF"/>
-                    </a:solidFill>
-                  </a:tcPr>
-                </a:tc>
-                <a:tc>
-                  <a:txBody>
-                    <a:bodyPr/>
-                    <a:lstStyle/>
-                    <a:p>
-                      <a:r>
-                        <a:rPr sz="1400">
-                          <a:solidFill>
-                            <a:srgbClr val="404040"/>
-                          </a:solidFill>
-                          <a:latin typeface="Calibri"/>
-                        </a:rPr>
                         <a:t>~35 min</a:t>
                       </a:r>
                     </a:p>
@@ -9384,28 +6873,6 @@
                           </a:solidFill>
                           <a:latin typeface="Calibri"/>
                         </a:rPr>
-                        <a:t>9</a:t>
-                      </a:r>
-                    </a:p>
-                  </a:txBody>
-                  <a:tcPr marL="54864" marR="54864" marT="27432" marB="27432" anchor="ctr">
-                    <a:solidFill>
-                      <a:srgbClr val="EEF6F1"/>
-                    </a:solidFill>
-                  </a:tcPr>
-                </a:tc>
-                <a:tc>
-                  <a:txBody>
-                    <a:bodyPr/>
-                    <a:lstStyle/>
-                    <a:p>
-                      <a:r>
-                        <a:rPr sz="1400">
-                          <a:solidFill>
-                            <a:srgbClr val="404040"/>
-                          </a:solidFill>
-                          <a:latin typeface="Calibri"/>
-                        </a:rPr>
                         <a:t>~35 min</a:t>
                       </a:r>
                     </a:p>
@@ -9430,7 +6897,7 @@
         <p:spPr>
           <a:xfrm>
             <a:off x="548640" y="3392424"/>
-            <a:ext cx="11064240" cy="1051560"/>
+            <a:ext cx="11064240" cy="1417320"/>
           </a:xfrm>
           <a:prstGeom prst="roundRect">
             <a:avLst>
@@ -9478,7 +6945,7 @@
         <p:spPr>
           <a:xfrm>
             <a:off x="731520" y="3465576"/>
-            <a:ext cx="10698480" cy="914400"/>
+            <a:ext cx="10698480" cy="1280160"/>
           </a:xfrm>
           <a:prstGeom prst="rect">
             <a:avLst/>
@@ -9555,7 +7022,113 @@
                 </a:solidFill>
                 <a:latin typeface="Calibri"/>
               </a:rPr>
-              <a:t>Leave stretch puzzles 5.2, 5.6, 6.3 for afterwards; they still count. Stuck? Run the solution cell so later parts work.</a:t>
+              <a:t>Leave stretch puzzles 5.2, 5.6, 6.3 for afterwards. Stuck? Run the solution cell so later parts work.</a:t>
+            </a:r>
+          </a:p>
+          <a:p>
+            <a:pPr algn="l">
+              <a:spcAft>
+                <a:spcPts val="600"/>
+              </a:spcAft>
+            </a:pPr>
+            <a:r>
+              <a:rPr sz="1500" b="1" i="0">
+                <a:solidFill>
+                  <a:srgbClr val="008759"/>
+                </a:solidFill>
+                <a:latin typeface="Calibri"/>
+              </a:rPr>
+              <a:t>Next time: </a:t>
+            </a:r>
+            <a:r>
+              <a:rPr sz="1500" b="0" i="0">
+                <a:solidFill>
+                  <a:srgbClr val="404040"/>
+                </a:solidFill>
+                <a:latin typeface="Calibri"/>
+              </a:rPr>
+              <a:t>Session 3 · Backprop and performance (Ch 7–8). Optional reading: book chapters 7–8.</a:t>
+            </a:r>
+          </a:p>
+        </p:txBody>
+      </p:sp>
+    </p:spTree>
+  </p:cSld>
+  <p:clrMapOvr>
+    <a:masterClrMapping/>
+  </p:clrMapOvr>
+</p:sld>
+</file>
+
+<file path=ppt/slides/slide8.xml><?xml version="1.0" encoding="utf-8"?>
+<p:sld xmlns:a="http://schemas.openxmlformats.org/drawingml/2006/main" xmlns:p="http://schemas.openxmlformats.org/presentationml/2006/main" xmlns:r="http://schemas.openxmlformats.org/officeDocument/2006/relationships">
+  <p:cSld>
+    <p:spTree>
+      <p:nvGrpSpPr>
+        <p:cNvPr id="1" name=""/>
+        <p:cNvGrpSpPr/>
+        <p:nvPr/>
+      </p:nvGrpSpPr>
+      <p:grpSpPr/>
+      <p:sp>
+        <p:nvSpPr>
+          <p:cNvPr id="2" name="Text Placeholder 1"/>
+          <p:cNvSpPr>
+            <a:spLocks noGrp="1"/>
+          </p:cNvSpPr>
+          <p:nvPr>
+            <p:ph type="body" idx="12" sz="quarter"/>
+          </p:nvPr>
+        </p:nvSpPr>
+        <p:spPr/>
+        <p:txBody>
+          <a:bodyPr/>
+          <a:lstStyle/>
+          <a:p>
+            <a:r>
+              <a:t>Transition Bio ML Reading Group</a:t>
+            </a:r>
+          </a:p>
+        </p:txBody>
+      </p:sp>
+      <p:sp>
+        <p:nvSpPr>
+          <p:cNvPr id="3" name="Title 2"/>
+          <p:cNvSpPr>
+            <a:spLocks noGrp="1"/>
+          </p:cNvSpPr>
+          <p:nvPr>
+            <p:ph type="ctrTitle"/>
+          </p:nvPr>
+        </p:nvSpPr>
+        <p:spPr/>
+        <p:txBody>
+          <a:bodyPr/>
+          <a:lstStyle/>
+          <a:p>
+            <a:r>
+              <a:t>Questions?</a:t>
+            </a:r>
+          </a:p>
+        </p:txBody>
+      </p:sp>
+      <p:sp>
+        <p:nvSpPr>
+          <p:cNvPr id="4" name="Text Placeholder 3"/>
+          <p:cNvSpPr>
+            <a:spLocks noGrp="1"/>
+          </p:cNvSpPr>
+          <p:nvPr>
+            <p:ph type="body" idx="11" sz="quarter"/>
+          </p:nvPr>
+        </p:nvSpPr>
+        <p:spPr/>
+        <p:txBody>
+          <a:bodyPr/>
+          <a:lstStyle/>
+          <a:p>
+            <a:r>
+              <a:t>Deep Learning in the Kalahari</a:t>
             </a:r>
           </a:p>
         </p:txBody>

</xml_diff>